<commit_message>
Adapt memory workshop to trading-support platform with visual banking demos, facilitator scripts and tool comparison
</commit_message>
<xml_diff>
--- a/workshop/presentation.pptx
+++ b/workshop/presentation.pptx
@@ -513,7 +513,73 @@
           <a:lstStyle/>
           <a:p>
             <a:r>
-              <a:t>0–2 min: hlasování. Kde dnes držíte paměť: historie, summary, SQL, vektory, graf? Vyberte jednu zkušenost účastníka.</a:t>
+              <a:t>Čas: 0–2 min</a:t>
+            </a:r>
+          </a:p>
+          <a:p/>
+          <a:p>
+            <a:r>
+              <a:t>Cíl slidu</a:t>
+            </a:r>
+          </a:p>
+          <a:p>
+            <a:r>
+              <a:t>Vysvětlit princip paměti na modelové platformě podpory burzovních obchodníků.</a:t>
+            </a:r>
+          </a:p>
+          <a:p/>
+          <a:p>
+            <a:r>
+              <a:t>Co říct nahlas (lze přečíst)</a:t>
+            </a:r>
+          </a:p>
+          <a:p>
+            <a:r>
+              <a:t>„Dnes použijeme příklady blízké naší podpůrné platformě pro obchodníky na burze. Agent má vysvětlit, odkud report čerpá data, co se změní při nové funkci a jak se dnes počítá finanční zdraví klienta. U každé otázky si ukážeme, proč nestačí najít text se správnými slovy. Potřebujeme dohledat skutečné zdroje a vazby a rozlišit platnou verzi od starého dokumentu. Nepracujeme s naším produkčním kódem ani skutečným klientem. Je to malá spustitelná modelová platforma, na které lze princip ověřit.“</a:t>
+            </a:r>
+          </a:p>
+          <a:p/>
+          <a:p>
+            <a:r>
+              <a:t>Co udělat</a:t>
+            </a:r>
+          </a:p>
+          <a:p>
+            <a:r>
+              <a:t>Zeptejte se: „Která z těchto tří otázek nám dnes zabere nejvíc času?“ Vyžádejte jednu odpověď, nejvýše 30 sekund.</a:t>
+            </a:r>
+          </a:p>
+          <a:p/>
+          <a:p>
+            <a:r>
+              <a:t>Očekávaná odpověď / výsledek</a:t>
+            </a:r>
+          </a:p>
+          <a:p>
+            <a:r>
+              <a:t>Libovolná z trojice je v pořádku. Připomeňte, že cílem je vysvětlit postup vybavení důkazů, ne zavádět nový produkt.</a:t>
+            </a:r>
+          </a:p>
+          <a:p/>
+          <a:p>
+            <a:r>
+              <a:t>Přechod na další slide</a:t>
+            </a:r>
+          </a:p>
+          <a:p>
+            <a:r>
+              <a:t>Pojďme stejný princip ověřit v dalším kroku.</a:t>
+            </a:r>
+          </a:p>
+          <a:p/>
+          <a:p>
+            <a:r>
+              <a:t>Na co si dát pozor</a:t>
+            </a:r>
+          </a:p>
+          <a:p>
+            <a:r>
+              <a:t>Nikdy neříkejte, že modelová formule je skutečný bankovní scoring nebo že graf zachycuje vaši produkci.</a:t>
             </a:r>
           </a:p>
         </p:txBody>
@@ -583,7 +649,73 @@
           <a:lstStyle/>
           <a:p>
             <a:r>
-              <a:t>21–24 min: v našem hybridu známe intent a entity ze zadání. V produkci změřte chyby routeru, extrakce i entity resolution; graf nevymyslí chybějící hranu. Aktualizace vlastníka má uzavřít valid_to starého tvrzení, zachovat audit a invalidovat cache.</a:t>
+              <a:t>Čas: 21–24 min</a:t>
+            </a:r>
+          </a:p>
+          <a:p/>
+          <a:p>
+            <a:r>
+              <a:t>Cíl slidu</a:t>
+            </a:r>
+          </a:p>
+          <a:p>
+            <a:r>
+              <a:t>Vysvětlit princip paměti na modelové platformě podpory burzovních obchodníků.</a:t>
+            </a:r>
+          </a:p>
+          <a:p/>
+          <a:p>
+            <a:r>
+              <a:t>Co říct nahlas (lze přečíst)</a:t>
+            </a:r>
+          </a:p>
+          <a:p>
+            <a:r>
+              <a:t>„Na otázku současný mechanismus nestačí odpovědět vzorcem nalezeným v dokumentaci. Musíme doložit verzi, která je nasazená k danému datu, její váhy a kód, který je používá. V modelové v2 je likvidita dostupná hotovost dělená očekávaným odtokem a potom dvěma, omezená na nula až jedna. Maržová komponenta je rezerva nad initial margin v poměru k equity, dělená půlkou, také omezená. Diverzifikace je jedna minus podíl největší pozice. Vážené komponenty vynásobíme stem. Výpočet zde slouží pro ilustraci vysvětlení původu čísla; nehodnotíme bonitu ani nepředstavujeme pravidlo naší banky.“</a:t>
+            </a:r>
+          </a:p>
+          <a:p/>
+          <a:p>
+            <a:r>
+              <a:t>Co udělat</a:t>
+            </a:r>
+          </a:p>
+          <a:p>
+            <a:r>
+              <a:t>Ukažte registry verze v1/v2/v3, pak tři komponenty a výsledek. Pokud je formule příliš detailní, stačí číst váhy a říct, že způsob normalizace je ve zdrojovém kódu. Zeptejte se: „Co by chybělo v odpovědi, kdybychom neuvedli verzi?“</a:t>
+            </a:r>
+          </a:p>
+          <a:p/>
+          <a:p>
+            <a:r>
+              <a:t>Očekávaná odpověď / výsledek</a:t>
+            </a:r>
+          </a:p>
+          <a:p>
+            <a:r>
+              <a:t>Nevíme, zda jsou pravidlo a váhy aktuální. 13. 10. 2026 vybere modelový registry health-v2; v3-draft není nasazený ani po svém navrženém datu.</a:t>
+            </a:r>
+          </a:p>
+          <a:p/>
+          <a:p>
+            <a:r>
+              <a:t>Přechod na další slide</a:t>
+            </a:r>
+          </a:p>
+          <a:p>
+            <a:r>
+              <a:t>Pojďme stejný princip ověřit v dalším kroku.</a:t>
+            </a:r>
+          </a:p>
+          <a:p/>
+          <a:p>
+            <a:r>
+              <a:t>Na co si dát pozor</a:t>
+            </a:r>
+          </a:p>
+          <a:p>
+            <a:r>
+              <a:t>Žádné produkční prahy nebo schvalovací rozhodnutí nejsou součástí modelu. Při historické otázce se mění váhy podle datové platnosti, ne podle názvu dokumentu.</a:t>
             </a:r>
           </a:p>
         </p:txBody>
@@ -653,7 +785,73 @@
           <a:lstStyle/>
           <a:p>
             <a:r>
-              <a:t>24–27 min: 2 min práce + 1 min dvě odpovědi. Očekávané řešení: preference přesný stav, incidenty epizody, vlastnictví verzované vztahy/stav. Test: historický vlastník k datu, nezáměnné identifikátory, konflikt zdrojů, tenant isolation.</a:t>
+              <a:t>Čas: 24–27 min</a:t>
+            </a:r>
+          </a:p>
+          <a:p/>
+          <a:p>
+            <a:r>
+              <a:t>Cíl slidu</a:t>
+            </a:r>
+          </a:p>
+          <a:p>
+            <a:r>
+              <a:t>Vysvětlit princip paměti na modelové platformě podpory burzovních obchodníků.</a:t>
+            </a:r>
+          </a:p>
+          <a:p/>
+          <a:p>
+            <a:r>
+              <a:t>Co říct nahlas (lze přečíst)</a:t>
+            </a:r>
+          </a:p>
+          <a:p>
+            <a:r>
+              <a:t>„Ve dvojicích navrhněte paměť pro asistenta podpory obchodníků. Má odpovídat na tři dnešní otázky a vejít podklady do tisíce tokenů. Nevybírejte hned značku databáze. Řekněte, které důkazy potřebujete, jak se k nim dostanete a jak poznáte platnou verzi. Přidejte test, který by chybný návrh odhalil. Například nový draft nesmí změnit odpověď na současný mechanismus. Máte dvě minuty, potom uslyšíme dvě třicetisekundové odpovědi.“</a:t>
+            </a:r>
+          </a:p>
+          <a:p/>
+          <a:p>
+            <a:r>
+              <a:t>Co udělat</a:t>
+            </a:r>
+          </a:p>
+          <a:p>
+            <a:r>
+              <a:t>24:00–26:00 práce dvojic, 26:00–27:00 dvě odpovědi. Při tichu nabídněte rozdělení text / graf / registry a zeptejte se na draft.</a:t>
+            </a:r>
+          </a:p>
+          <a:p/>
+          <a:p>
+            <a:r>
+              <a:t>Očekávaná odpověď / výsledek</a:t>
+            </a:r>
+          </a:p>
+          <a:p>
+            <a:r>
+              <a:t>Lineage přes datové vazby, dopady přes volající funkce, mechanismus přes platnou verzi a kód. Text pomáhá s popisy a zkušenostmi. Přijměte SQL joiny jako strukturovanou alternativu.</a:t>
+            </a:r>
+          </a:p>
+          <a:p/>
+          <a:p>
+            <a:r>
+              <a:t>Přechod na další slide</a:t>
+            </a:r>
+          </a:p>
+          <a:p>
+            <a:r>
+              <a:t>Pojďme stejný princip ověřit v dalším kroku.</a:t>
+            </a:r>
+          </a:p>
+          <a:p/>
+          <a:p>
+            <a:r>
+              <a:t>Na co si dát pozor</a:t>
+            </a:r>
+          </a:p>
+          <a:p>
+            <a:r>
+              <a:t>Graf musí zachytit čerstvý commit; pro dynamické volání mohou být nutné testy. Nejde jen o výběr úložiště.</a:t>
             </a:r>
           </a:p>
         </p:txBody>
@@ -723,7 +921,73 @@
           <a:lstStyle/>
           <a:p>
             <a:r>
-              <a:t>27–30 min: 2 min otázky, 1 min závěr. Vyberte 20 skutečných dotazů vašeho týmu a porovnejte na stejném token budgetu: lexical, neural, SQL, graph a hybrid. Předem definujte gold, validitu, abstenci a náklady. Na 30 min skončete.</a:t>
+              <a:t>Čas: 27–30 min</a:t>
+            </a:r>
+          </a:p>
+          <a:p/>
+          <a:p>
+            <a:r>
+              <a:t>Cíl slidu</a:t>
+            </a:r>
+          </a:p>
+          <a:p>
+            <a:r>
+              <a:t>Uzavřít bez tvrzení, že jedna struktura řeší všechny paměťové problémy.</a:t>
+            </a:r>
+          </a:p>
+          <a:p/>
+          <a:p>
+            <a:r>
+              <a:t>Co říct nahlas (lze přečíst)</a:t>
+            </a:r>
+          </a:p>
+          <a:p>
+            <a:r>
+              <a:t>„Dnes jsme viděli, že podobnost textu, přesná hodnota a vztah mezi objekty jsou různé potřeby. U podobného incidentu může stačit textové hledání. U verze mechanismu potřebujeme platný stav a u lineage reportu konkrétní návaznost. Kombinace může zmenšit kontext, ale přináší také práci s extrakcí, aktualizacemi a výběrem správné cesty. Proto bych jako další krok nevolil okamžitě migraci na nový nástroj. Vybral bych skutečný report, jednu feature a několik časových otázek našeho týmu, určil potřebné důkazy a na nich porovnal jednoduchou variantu s kandidáty. Při výběru se ptejme nejen, zda systém něco našel, ale zda našel to, co odpověď potřebuje.“</a:t>
+            </a:r>
+          </a:p>
+          <a:p/>
+          <a:p>
+            <a:r>
+              <a:t>Co udělat</a:t>
+            </a:r>
+          </a:p>
+          <a:p>
+            <a:r>
+              <a:t>27:00–29:00: dvě otázky z publika, případně z připraveného FAQ. 29:00–30:00: přečtěte závěrečný odstavec a ukažte odkaz na podklady. Ve 30:00 skončete.</a:t>
+            </a:r>
+          </a:p>
+          <a:p/>
+          <a:p>
+            <a:r>
+              <a:t>Očekávaná odpověď / výsledek</a:t>
+            </a:r>
+          </a:p>
+          <a:p>
+            <a:r>
+              <a:t>Účastníci by měli umět rozlišit tři úlohy, popsat přínos struktury a vědět, že naše výsledky mají omezený rozsah.</a:t>
+            </a:r>
+          </a:p>
+          <a:p/>
+          <a:p>
+            <a:r>
+              <a:t>Přechod na další slide</a:t>
+            </a:r>
+          </a:p>
+          <a:p>
+            <a:r>
+              <a:t>„Podklady, zdrojový kód a měření jsou v repozitáři; detailní otázky můžeme rozebrat po meetingu.“</a:t>
+            </a:r>
+          </a:p>
+          <a:p/>
+          <a:p>
+            <a:r>
+              <a:t>Na co si dát pozor</a:t>
+            </a:r>
+          </a:p>
+          <a:p>
+            <a:r>
+              <a:t>Na otázku, kterou neumíte zodpovědět, použijte: „Tohle jsme v ukázce neměřili; ověřme konkrétní verzi a přidejme test.“ Neimprovizujte produktové sliby.</a:t>
             </a:r>
           </a:p>
         </p:txBody>
@@ -793,7 +1057,73 @@
           <a:lstStyle/>
           <a:p>
             <a:r>
-              <a:t>2–4 min: ukažte cestu událost → zápis → index → retrieval → prompt. V našem měření počítáme UTF‑8 bajty, nikoli tokeny. KV cache je jiná vrstva optimalizace.</a:t>
+              <a:t>Čas: 2–4 min</a:t>
+            </a:r>
+          </a:p>
+          <a:p/>
+          <a:p>
+            <a:r>
+              <a:t>Cíl slidu</a:t>
+            </a:r>
+          </a:p>
+          <a:p>
+            <a:r>
+              <a:t>Zabránit záměně menšího promptu, menší databáze a menší RAM.</a:t>
+            </a:r>
+          </a:p>
+          <a:p/>
+          <a:p>
+            <a:r>
+              <a:t>Co říct nahlas (lze přečíst)</a:t>
+            </a:r>
+          </a:p>
+          <a:p>
+            <a:r>
+              <a:t>„Představte si knihovnu. V regálech může být tisíc knih, ale pro jednu odpověď otevřeme jen několik stránek. Regály odpovídají úložišti a vybrané stránky kontextu modelu. Vytvořit index nám pomůže stránky najít, ale index sám zabere další místo. Proto graf ani vektorová databáze automaticky nezmenšují celou paměť systému. Často šetří hlavně to, co předáváme modelu. Token je jednotka textu používaná modelem, přibližně část slova. My zde počítáme bajty textu: snadno je změříme, ale nejsou totéž co tokeny.“</a:t>
+            </a:r>
+          </a:p>
+          <a:p/>
+          <a:p>
+            <a:r>
+              <a:t>Co udělat</a:t>
+            </a:r>
+          </a:p>
+          <a:p>
+            <a:r>
+              <a:t>Ukažte postup „uložené zdroje → vyhledání → několik důkazů → model“. Zeptejte se: „Když přidáme index, musí se zmenšit databáze?“</a:t>
+            </a:r>
+          </a:p>
+          <a:p/>
+          <a:p>
+            <a:r>
+              <a:t>Očekávaná odpověď / výsledek</a:t>
+            </a:r>
+          </a:p>
+          <a:p>
+            <a:r>
+              <a:t>Ne. Index může úložiště i RAM zvětšit, přesto zmenšit vrácený kontext.</a:t>
+            </a:r>
+          </a:p>
+          <a:p/>
+          <a:p>
+            <a:r>
+              <a:t>Přechod na další slide</a:t>
+            </a:r>
+          </a:p>
+          <a:p>
+            <a:r>
+              <a:t>„Teď se podíváme na několik způsobů, jak ty regály a kartotéku uspořádat.“</a:t>
+            </a:r>
+          </a:p>
+          <a:p/>
+          <a:p>
+            <a:r>
+              <a:t>Na co si dát pozor</a:t>
+            </a:r>
+          </a:p>
+          <a:p>
+            <a:r>
+              <a:t>Úspora bajtů v našich výsledcích není změřená úspora RAM, tokenů ani finančních nákladů.</a:t>
             </a:r>
           </a:p>
         </p:txBody>
@@ -863,7 +1193,73 @@
           <a:lstStyle/>
           <a:p>
             <a:r>
-              <a:t>4–6 min: preference uživatele patří do stavu, incident do epizody, závislost do vztahu. Stejný záznam lze indexovat několika způsoby. Procedurální paměť = ověřené postupy/runbooky; sémantická = fakta; epizodická = události.</a:t>
+              <a:t>Čas: 4–6 min</a:t>
+            </a:r>
+          </a:p>
+          <a:p/>
+          <a:p>
+            <a:r>
+              <a:t>Cíl slidu</a:t>
+            </a:r>
+          </a:p>
+          <a:p>
+            <a:r>
+              <a:t>Ukázat, že graf a vektory nejsou jediné možnosti.</a:t>
+            </a:r>
+          </a:p>
+          <a:p/>
+          <a:p>
+            <a:r>
+              <a:t>Co říct nahlas (lze přečíst)</a:t>
+            </a:r>
+          </a:p>
+          <a:p>
+            <a:r>
+              <a:t>„Historie je nejjednodušší: uchováme, co se stalo. Čím je delší, tím obtížněji ji celou předáváme modelu. Souhrn pomůže, ale třeba vypustí větu, že určitý postup neplatí pro produkci. Přesné nastavení, jako měna reportu, je obvykle lepší uložit do pojmenovaného pole nebo tabulky. Incident je naproti tomu příběh s příznaky a řešením, takže se hodí text. A pokud potřebujeme vědět, které služby závisejí na které databázi, pomůže explicitní síť vztahů. Nemusíme vybrat jedinou strukturu pro všechno. Jedna událost může mít textový originál i strukturované údaje.“</a:t>
+            </a:r>
+          </a:p>
+          <a:p/>
+          <a:p>
+            <a:r>
+              <a:t>Co udělat</a:t>
+            </a:r>
+          </a:p>
+          <a:p>
+            <a:r>
+              <a:t>Požádejte jednoho účastníka, aby zařadil informaci „report klienta je v EUR“. Potom informaci „timeout jsme vyřešili omezením souběžných požadavků“.</a:t>
+            </a:r>
+          </a:p>
+          <a:p/>
+          <a:p>
+            <a:r>
+              <a:t>Očekávaná odpověď / výsledek</a:t>
+            </a:r>
+          </a:p>
+          <a:p>
+            <a:r>
+              <a:t>Jazyk: přesný stav v JSON/SQL. Postup řešení incidentu: textová zkušenost, případně ověřený návod.</a:t>
+            </a:r>
+          </a:p>
+          <a:p/>
+          <a:p>
+            <a:r>
+              <a:t>Přechod na další slide</a:t>
+            </a:r>
+          </a:p>
+          <a:p>
+            <a:r>
+              <a:t>„Na stejných datech si ukážeme tři otázky, které potřebují různé druhy paměti.“</a:t>
+            </a:r>
+          </a:p>
+          <a:p/>
+          <a:p>
+            <a:r>
+              <a:t>Na co si dát pozor</a:t>
+            </a:r>
+          </a:p>
+          <a:p>
+            <a:r>
+              <a:t>Souhrn, SQL a graf mohou být stejně užitečné. Nevytvářejte dojem, že graf je automaticky nejpokročilejší správné řešení.</a:t>
             </a:r>
           </a:p>
         </p:txBody>
@@ -933,7 +1329,73 @@
           <a:lstStyle/>
           <a:p>
             <a:r>
-              <a:t>6–8 min: dejte 30 sekund ve dvojicích. Jde o realistické, ale syntetické scénáře, nikoli záznamy skutečného incidentu. Každý typ má osm variant.</a:t>
+              <a:t>Čas: 6–8 min</a:t>
+            </a:r>
+          </a:p>
+          <a:p/>
+          <a:p>
+            <a:r>
+              <a:t>Cíl slidu</a:t>
+            </a:r>
+          </a:p>
+          <a:p>
+            <a:r>
+              <a:t>Vysvětlit princip paměti na modelové platformě podpory burzovních obchodníků.</a:t>
+            </a:r>
+          </a:p>
+          <a:p/>
+          <a:p>
+            <a:r>
+              <a:t>Co říct nahlas (lze přečíst)</a:t>
+            </a:r>
+          </a:p>
+          <a:p>
+            <a:r>
+              <a:t>„První otázka začíná výsledkem, tedy reportem, a jde zpět ke zdrojům. Druhá začíná změnou funkce a jde opačně k místům, která funkci používají. Třetí potřebuje zjistit nejen vzorec v kódu, ale i to, která verze a váhy jsou skutečně nasazené. Dokument s názvem současný výpočet může být jen návrh. Tyto otázky jsou záměrně o vazbách a platnosti. Výsledky nám proto neřeknou, jak dobře bychom našli podobný incident nebo parafrázi v dokumentech.“</a:t>
+            </a:r>
+          </a:p>
+          <a:p/>
+          <a:p>
+            <a:r>
+              <a:t>Co udělat</a:t>
+            </a:r>
+          </a:p>
+          <a:p>
+            <a:r>
+              <a:t>Dejte dvojicím 30 sekund. Potom vysvětlete: report má lineage; feature má call graph; mechanismus má deployment registry a kód. Call graph znamená graf, kdo kterou funkci volá.</a:t>
+            </a:r>
+          </a:p>
+          <a:p/>
+          <a:p>
+            <a:r>
+              <a:t>Očekávaná odpověď / výsledek</a:t>
+            </a:r>
+          </a:p>
+          <a:p>
+            <a:r>
+              <a:t>A: nestačí uživatelský popis reportu. B: nestačí návrh nové feature. C: nestačí staré pravidlo ani nenasazený draft.</a:t>
+            </a:r>
+          </a:p>
+          <a:p/>
+          <a:p>
+            <a:r>
+              <a:t>Přechod na další slide</a:t>
+            </a:r>
+          </a:p>
+          <a:p>
+            <a:r>
+              <a:t>Pojďme stejný princip ověřit v dalším kroku.</a:t>
+            </a:r>
+          </a:p>
+          <a:p/>
+          <a:p>
+            <a:r>
+              <a:t>Na co si dát pozor</a:t>
+            </a:r>
+          </a:p>
+          <a:p>
+            <a:r>
+              <a:t>Tři otázky nejsou reprezentativní test všech možností paměti. Záměrně odpovídají potřebám podpůrné platformy.</a:t>
             </a:r>
           </a:p>
         </p:txBody>
@@ -1003,7 +1465,73 @@
           <a:lstStyle/>
           <a:p>
             <a:r>
-              <a:t>8–10 min: ukažte diagram svc-0 → db-0 → team-0. Druhá hrana neobsahuje svc-0; textová podobnost nemá důvod ji vrátit. GraphRAG je širší rodina postupů, ne synonymum pro každý graf.</a:t>
+              <a:t>Čas: 8–10 min</a:t>
+            </a:r>
+          </a:p>
+          <a:p/>
+          <a:p>
+            <a:r>
+              <a:t>Cíl slidu</a:t>
+            </a:r>
+          </a:p>
+          <a:p>
+            <a:r>
+              <a:t>Vysvětlit princip paměti na modelové platformě podpory burzovních obchodníků.</a:t>
+            </a:r>
+          </a:p>
+          <a:p/>
+          <a:p>
+            <a:r>
+              <a:t>Co říct nahlas (lze přečíst)</a:t>
+            </a:r>
+          </a:p>
+          <a:p>
+            <a:r>
+              <a:t>„Vlevo je textový vyhledávač. Najde například popis reportu, protože se velmi podobá otázce. To nám pomůže se zorientovat, ale ještě z toho nevíme, odkud přichází každé číslo. Vpravo je graf vytvořený ze skutečných volání v našem modelovém kódu a deklarací datových zdrojů. Z reportu přejdeme k PnL a finančnímu zdraví a dál ke zdrojům. Skóre podobnosti je číslo, ne pravděpodobnost pravdivosti. Oranžový dokument není nutně chybný: prostě neposkytuje potřebný důkaz. V ukázce známe počáteční funkci předem, což je důležitá výhoda grafového postupu.“</a:t>
+            </a:r>
+          </a:p>
+          <a:p/>
+          <a:p>
+            <a:r>
+              <a:t>Co udělat</a:t>
+            </a:r>
+          </a:p>
+          <a:p>
+            <a:r>
+              <a:t>V HTML nechte otázku A (report) a top-k 4. Klikněte Uložení, Otázka, Hledání, Důkazy. Na každý krok 15–20 sekund. Ukažte vlevo doc-weekly-report, vpravo návaznost k datovým zdrojům. V PDF/PPTX je zobrazený konečný stav.</a:t>
+            </a:r>
+          </a:p>
+          <a:p/>
+          <a:p>
+            <a:r>
+              <a:t>Očekávaná odpověď / výsledek</a:t>
+            </a:r>
+          </a:p>
+          <a:p>
+            <a:r>
+              <a:t>Vektor@4 má 0/9 definovaných důkazů lineage; strukturovaný průchod 9/9. Popis reportu se neshoduje se seznamem kódu a zdrojů, který potřebujeme.</a:t>
+            </a:r>
+          </a:p>
+          <a:p/>
+          <a:p>
+            <a:r>
+              <a:t>Přechod na další slide</a:t>
+            </a:r>
+          </a:p>
+          <a:p>
+            <a:r>
+              <a:t>„Teď začneme naopak od místa, které chceme změnit, a potom se podíváme na platnou verzi výpočtu.“</a:t>
+            </a:r>
+          </a:p>
+          <a:p/>
+          <a:p>
+            <a:r>
+              <a:t>Na co si dát pozor</a:t>
+            </a:r>
+          </a:p>
+          <a:p>
+            <a:r>
+              <a:t>Vektorový baseline je TF-IDF nad českými otázkami a převážně anglickým kódem. Nejde o test neuronových embeddingů. S devíti potřebnými důkazy nemůže top-4 vytvořit úplnou sadu; tento fakt vyslovte.</a:t>
             </a:r>
           </a:p>
         </p:txBody>
@@ -1073,7 +1601,83 @@
           <a:lstStyle/>
           <a:p>
             <a:r>
-              <a:t>10–15 min: A 90 s, B 90 s, skutečný kód 2 min (source-demo.html); C volitelně po meetingu. U B ukažte očekávané ID i chybějící ID. C není kompletní temporal engine: aktuální stav je ručně materializovaný. Nezavádějte žádné API klíče, vše běží offline.</a:t>
+              <a:t>Čas: 10–15 min</a:t>
+            </a:r>
+          </a:p>
+          <a:p/>
+          <a:p>
+            <a:r>
+              <a:t>Cíl slidu</a:t>
+            </a:r>
+          </a:p>
+          <a:p>
+            <a:r>
+              <a:t>Vysvětlit princip paměti na modelové platformě podpory burzovních obchodníků.</a:t>
+            </a:r>
+          </a:p>
+          <a:p/>
+          <a:p>
+            <a:r>
+              <a:t>Co říct nahlas (lze přečíst)</a:t>
+            </a:r>
+          </a:p>
+          <a:p>
+            <a:r>
+              <a:t>„Při feature what-if margin chceme změnit výpočet maržové rezervy. Nestačí najít návrh této feature. Potřebujeme vědět, že funkci volá výpočet finančního zdraví a ten dále používá report i dashboard obchodníka. U mechanismu skóre zase vybíráme nejprve nasazenou verzi z registru. Historická v1 a budoucí návrh v3 jsou v paměti, ale nepředstavují současný stav. Nasazená v2 kombinuje likviditu, maržovou rezervu a diverzifikaci. Výsledné číslo je pouze modelová ukázka: neznáme skutečné pravidlo naší banky.“</a:t>
+            </a:r>
+          </a:p>
+          <a:p/>
+          <a:p>
+            <a:r>
+              <a:t>Co udělat</a:t>
+            </a:r>
+          </a:p>
+          <a:p>
+            <a:r>
+              <a:t>10:00–12:00 — Otevřete bank-visual.html. Vyberte B (what-if margin), top-k 4. Nechte tipnout dvě dotčená místa. Klikněte na Hledání a Důkazy. Ukažte šipky od calculate_margin_buffer přes calculate_financial_health do reportu a dashboardu.</a:t>
+            </a:r>
+          </a:p>
+          <a:p>
+            <a:r>
+              <a:t>12:00–14:00 — Vyberte C (současný mechanismus). Klikněte Otázka, Hledání, Důkazy. Vlevo ukažte historický dokument a draft. Vpravo porovnejte stav v1, nasazené v2 a nenasazené v3.</a:t>
+            </a:r>
+          </a:p>
+          <a:p>
+            <a:r>
+              <a:t>14:00–15:00 — Přečtěte skóre 54,67. Řekněte, že kód byl skutečně spuštěn, ne že odpověděl LLM. Vraťte se na prezentaci. Python není potřeba spouštět během meetingu.</a:t>
+            </a:r>
+          </a:p>
+          <a:p/>
+          <a:p>
+            <a:r>
+              <a:t>Očekávaná odpověď / výsledek</a:t>
+            </a:r>
+          </a:p>
+          <a:p>
+            <a:r>
+              <a:t>B/vector@4: 1/3 důkazů dopadu; graf: 3/3. C/vector@4: 0/6 potřebných důkazů mechanismu; registr + graf: 6/6. generate_weekly_report má PnL 460 EUR a skóre 54,67, verzi health-v2.</a:t>
+            </a:r>
+          </a:p>
+          <a:p/>
+          <a:p>
+            <a:r>
+              <a:t>Přechod na další slide</a:t>
+            </a:r>
+          </a:p>
+          <a:p>
+            <a:r>
+              <a:t>Pojďme stejný princip ověřit v dalším kroku.</a:t>
+            </a:r>
+          </a:p>
+          <a:p/>
+          <a:p>
+            <a:r>
+              <a:t>Na co si dát pozor</a:t>
+            </a:r>
+          </a:p>
+          <a:p>
+            <a:r>
+              <a:t>Šipky u dopadů jsou směr analýzy od změny k volajícím, opačný než původní CALLS. Stará verze i draft mohou být užitečné pro jiné otázky; pro dnešní mechanismus ale nestačí.</a:t>
             </a:r>
           </a:p>
         </p:txBody>
@@ -1143,7 +1747,73 @@
           <a:lstStyle/>
           <a:p>
             <a:r>
-              <a:t>15–17 min: celé tělo textu je vraceno, žádné ořezávání do stejného budgetu. full má neomezený kontext. Dotazy sdílejí šablony: 24 není 24 nezávislých problémů. Latence neobsahuje LLM, síť, ingest ani klasifikaci dotazu.</a:t>
+              <a:t>Čas: 15–17 min</a:t>
+            </a:r>
+          </a:p>
+          <a:p/>
+          <a:p>
+            <a:r>
+              <a:t>Cíl slidu</a:t>
+            </a:r>
+          </a:p>
+          <a:p>
+            <a:r>
+              <a:t>Vysvětlit princip paměti na modelové platformě podpory burzovních obchodníků.</a:t>
+            </a:r>
+          </a:p>
+          <a:p/>
+          <a:p>
+            <a:r>
+              <a:t>Co říct nahlas (lze přečíst)</a:t>
+            </a:r>
+          </a:p>
+          <a:p>
+            <a:r>
+              <a:t>„Máme tři konkrétní otázky. Pro každou jsme určili, které zdroje musí odpověď doložit. U reportu je to devět důkazů lineage, u feature tři dotčená místa a u mechanismu šest zdrojů pravidla. Gold je název tohoto očekávaného seznamu. Sledujeme, zda se podařilo najít vše, a kolik textu vracíme. Strukturovaný postup prochází skutečný AST graf modelového kódu. AST je struktura programu přečtená parserem. U současného mechanismu navíc přesně filtruje registr verzí. Výběr počátečního symbolu a typu otázky máme zadaný předem.“</a:t>
+            </a:r>
+          </a:p>
+          <a:p/>
+          <a:p>
+            <a:r>
+              <a:t>Co udělat</a:t>
+            </a:r>
+          </a:p>
+          <a:p>
+            <a:r>
+              <a:t>Ukažte příklad 1/3 u feature. Zeptejte se: „Stačí to pro seznam všech dopadů?“ Pak vysvětlete, že čas hledání se opakoval 50krát a nezahrnuje ingest ani rozpoznání otázky.</a:t>
+            </a:r>
+          </a:p>
+          <a:p/>
+          <a:p>
+            <a:r>
+              <a:t>Očekávaná odpověď / výsledek</a:t>
+            </a:r>
+          </a:p>
+          <a:p>
+            <a:r>
+              <a:t>Nestačí. Chybí dvě používaná místa. Nalezené dokumenty ani úplná sada samy nedokazují správnou odpověď LLM.</a:t>
+            </a:r>
+          </a:p>
+          <a:p/>
+          <a:p>
+            <a:r>
+              <a:t>Přechod na další slide</a:t>
+            </a:r>
+          </a:p>
+          <a:p>
+            <a:r>
+              <a:t>Pojďme stejný princip ověřit v dalším kroku.</a:t>
+            </a:r>
+          </a:p>
+          <a:p/>
+          <a:p>
+            <a:r>
+              <a:t>Na co si dát pozor</a:t>
+            </a:r>
+          </a:p>
+          <a:p>
+            <a:r>
+              <a:t>Budget není stejný: top-4 versus plný průchod. Český dotaz/anglický kód znevýhodňuje slovní baseline. Výsledky nelze přenést na neural RAG, Graphify nebo produkční banku.</a:t>
             </a:r>
           </a:p>
         </p:txBody>
@@ -1213,7 +1883,73 @@
           <a:lstStyle/>
           <a:p>
             <a:r>
-              <a:t>17–19 min: ukažte graf a důkazy. Hybrid vrací asi o 96 % méně bajtů než full, ale data i routování jsou idealizované. Čísla nepřenášet na produkční vector DB / graph DB. Grafové cesty jsou dictionary lookup, vektory sparse exact cosine, ne ANN.</a:t>
+              <a:t>Čas: 17–19 min</a:t>
+            </a:r>
+          </a:p>
+          <a:p/>
+          <a:p>
+            <a:r>
+              <a:t>Cíl slidu</a:t>
+            </a:r>
+          </a:p>
+          <a:p>
+            <a:r>
+              <a:t>Přečíst skutečné výsledky a jejich omezení.</a:t>
+            </a:r>
+          </a:p>
+          <a:p/>
+          <a:p>
+            <a:r>
+              <a:t>Co říct nahlas (lze přečíst)</a:t>
+            </a:r>
+          </a:p>
+          <a:p>
+            <a:r>
+              <a:t>„Celý archiv obsahuje všechny podklady, takže má úplnost tři ze tří, ale posílá 5 885 bajtů textu. Vektorový top-4 vrací průměrně 1 089 bajtů a pro naše tři strukturované otázky nemá úplnou sadu. Graf s registrem má úplné sady pro tři otázky a vrací průměrně 2 650 bajtů. Tedy není nejmenší: vrací i zdroje, které potřebujeme. Oproti celému archivu omezí text asi o 55 procent. To podporuje názornou myšlenku vybavení podle vazeb, ale není to obecný důkaz vítězství grafů. Úlohy jsme zvolili podle potřeb platformy a rozpočty strategií nejsou stejné.“</a:t>
+            </a:r>
+          </a:p>
+          <a:p/>
+          <a:p>
+            <a:r>
+              <a:t>Co udělat</a:t>
+            </a:r>
+          </a:p>
+          <a:p>
+            <a:r>
+              <a:t>Ukažte vlevo úplnost, vpravo velikost textu. Porovnejte nejprve full/structure, potom vector/structure. Nečtěte drobné časy.</a:t>
+            </a:r>
+          </a:p>
+          <a:p/>
+          <a:p>
+            <a:r>
+              <a:t>Očekávaná odpověď / výsledek</a:t>
+            </a:r>
+          </a:p>
+          <a:p>
+            <a:r>
+              <a:t>full 3/3; vector 0/3; structure 3/3. Context 5 885, 1 089 a 2 650 B. Méně textu není výhra, pokud chybí důkaz.</a:t>
+            </a:r>
+          </a:p>
+          <a:p/>
+          <a:p>
+            <a:r>
+              <a:t>Přechod na další slide</a:t>
+            </a:r>
+          </a:p>
+          <a:p>
+            <a:r>
+              <a:t>„Které nástroje takové vazby umějí zprostředkovat agentovi?“</a:t>
+            </a:r>
+          </a:p>
+          <a:p/>
+          <a:p>
+            <a:r>
+              <a:t>Na co si dát pozor</a:t>
+            </a:r>
+          </a:p>
+          <a:p>
+            <a:r>
+              <a:t>Důvody omezení: tři otázky, modelová data, TF-IDF, české dotazy a anglický kód, známý router/symbol, různý budget. Chyby extrakce a skutečné LLM odpovědi je potřeba měřit zvlášť.</a:t>
             </a:r>
           </a:p>
         </p:txBody>
@@ -1283,7 +2019,73 @@
           <a:lstStyle/>
           <a:p>
             <a:r>
-              <a:t>19–21 min: před odhalením tipněte, zda k=8 opraví B. Všechny hodnoty jsou skutečně změřené nad stejnými daty. Zvyšování k není náhradou za návaznost vztahů a časové filtry.</a:t>
+              <a:t>Čas: 19–21 min</a:t>
+            </a:r>
+          </a:p>
+          <a:p/>
+          <a:p>
+            <a:r>
+              <a:t>Cíl slidu</a:t>
+            </a:r>
+          </a:p>
+          <a:p>
+            <a:r>
+              <a:t>Představit výběr nástrojů bez potřeby znát jejich instalaci či architekturu.</a:t>
+            </a:r>
+          </a:p>
+          <a:p/>
+          <a:p>
+            <a:r>
+              <a:t>Co říct nahlas (lze přečíst)</a:t>
+            </a:r>
+          </a:p>
+          <a:p>
+            <a:r>
+              <a:t>„Názvy nástrojů berte jako kandidáty pro různé úlohy. Graphify a GitNexus jsou nejbližší naší ukázce dopadů what-if margin: pomáhají agentovi orientovat se ve struktuře repozitáře. Graphify zde označuje Graphify-Labs a používá grafové vybavení; GitNexus nabízí i kombinaci textových signálů. Graphiti se zaměřuje na fakta s časovou platností. Cognee a Mem0 jsou kandidáti pro paměť znalostí a interakcí, ale záleží na konkrétní verzi a nasazení. LightRAG a GraphRAG míří na otázky nad dokumenty. Jejich vlastnosti jsme ověřili v dokumentaci, tyto produkty jsme však v našem měření nespouštěli.“</a:t>
+            </a:r>
+          </a:p>
+          <a:p/>
+          <a:p>
+            <a:r>
+              <a:t>Co udělat</a:t>
+            </a:r>
+          </a:p>
+          <a:p>
+            <a:r>
+              <a:t>Volitelně otevřete tools-comparison.html, první nástroj Graphify, druhý GitNexus. Ukažte řádky „Vhodné použití“ a „Co ověřit“. Nečtěte všech sedm nástrojů ani neinstalujte software. Při nedostatku času zůstaňte na slidu.</a:t>
+            </a:r>
+          </a:p>
+          <a:p/>
+          <a:p>
+            <a:r>
+              <a:t>Očekávaná odpověď / výsledek</a:t>
+            </a:r>
+          </a:p>
+          <a:p>
+            <a:r>
+              <a:t>Pro dopady funkce se nejprve nabízí Graphify/GitNexus; pro časovou historii Graphiti a SQL baseline. Volba není pořadí kvality.</a:t>
+            </a:r>
+          </a:p>
+          <a:p/>
+          <a:p>
+            <a:r>
+              <a:t>Přechod na další slide</a:t>
+            </a:r>
+          </a:p>
+          <a:p>
+            <a:r>
+              <a:t>„Ať vybereme kterýkoli nástroj, musíme navrhnout, co se při změně informace stane.“</a:t>
+            </a:r>
+          </a:p>
+          <a:p/>
+          <a:p>
+            <a:r>
+              <a:t>Na co si dát pozor</a:t>
+            </a:r>
+          </a:p>
+          <a:p>
+            <a:r>
+              <a:t>Graphify není Graphiti. OSS je otevřená varianta softwaru; hosted Platform je spravovaná služba, jejíž vlastnosti mohou být jiné. Aktuální primární zdroje a rozdíly jsou v tools-comparison.md.</a:t>
             </a:r>
           </a:p>
         </p:txBody>
@@ -4370,7 +5172,7 @@
               </a:defRPr>
             </a:pPr>
             <a:r>
-              <a:t>Paměť agenta: co uložit, co vybavit</a:t>
+              <a:t>Paměť agenta pro podporu obchodníků</a:t>
             </a:r>
           </a:p>
         </p:txBody>
@@ -4409,7 +5211,7 @@
               </a:defRPr>
             </a:pPr>
             <a:r>
-              <a:t>30 minut • workshop pro vývojáře</a:t>
+              <a:t>30 minut · od dat reportu až k mechanismu výpočtu</a:t>
             </a:r>
           </a:p>
         </p:txBody>
@@ -4423,7 +5225,7 @@
         <p:spPr>
           <a:xfrm>
             <a:off x="640080" y="2560320"/>
-            <a:ext cx="10972800" cy="3931920"/>
+            <a:ext cx="10972800" cy="3200400"/>
           </a:xfrm>
           <a:prstGeom prst="rect">
             <a:avLst/>
@@ -4440,7 +5242,7 @@
               <a:spcAft>
                 <a:spcPts val="1400"/>
               </a:spcAft>
-              <a:defRPr sz="2300">
+              <a:defRPr sz="2000">
                 <a:solidFill>
                   <a:srgbClr val="F0F4FF"/>
                 </a:solidFill>
@@ -4448,7 +5250,7 @@
               </a:defRPr>
             </a:pPr>
             <a:r>
-              <a:t>• Cíl: zvolit strukturu podle otázky a rozpočtu kontextu.</a:t>
+              <a:t>• Agent má vysvětlit report, dopady změny kódu a aktuální výpočet skóre.</a:t>
             </a:r>
           </a:p>
           <a:p>
@@ -4456,7 +5258,7 @@
               <a:spcAft>
                 <a:spcPts val="1400"/>
               </a:spcAft>
-              <a:defRPr sz="2300">
+              <a:defRPr sz="2000">
                 <a:solidFill>
                   <a:srgbClr val="F0F4FF"/>
                 </a:solidFill>
@@ -4464,7 +5266,7 @@
               </a:defRPr>
             </a:pPr>
             <a:r>
-              <a:t>• Budeme předpovídat výsledky, procházet důkazy a měnit top‑k.</a:t>
+              <a:t>• Nestačí podobný dokument: potřebujeme zdroje, vazby a správnou verzi.</a:t>
             </a:r>
           </a:p>
           <a:p>
@@ -4472,7 +5274,7 @@
               <a:spcAft>
                 <a:spcPts val="1400"/>
               </a:spcAft>
-              <a:defRPr sz="2300">
+              <a:defRPr sz="2000">
                 <a:solidFill>
                   <a:srgbClr val="F0F4FF"/>
                 </a:solidFill>
@@ -4480,7 +5282,62 @@
               </a:defRPr>
             </a:pPr>
             <a:r>
-              <a:t>• Paměť zde = uložená data + pravidla zápisu + vybavení do promptu.</a:t>
+              <a:t>• Ukážeme stejné otázky přes textové hledání a přes strukturovanou paměť.</a:t>
+            </a:r>
+          </a:p>
+          <a:p>
+            <a:pPr>
+              <a:spcAft>
+                <a:spcPts val="1400"/>
+              </a:spcAft>
+              <a:defRPr sz="2000">
+                <a:solidFill>
+                  <a:srgbClr val="F0F4FF"/>
+                </a:solidFill>
+                <a:latin typeface="DejaVu Sans"/>
+              </a:defRPr>
+            </a:pPr>
+            <a:r>
+              <a:t>• Platforma i klient jsou modeloví; kód a naměřené výsledky jsou přiložené.</a:t>
+            </a:r>
+          </a:p>
+        </p:txBody>
+      </p:sp>
+      <p:sp>
+        <p:nvSpPr>
+          <p:cNvPr id="6" name="TextBox 5"/>
+          <p:cNvSpPr txBox="1"/>
+          <p:nvPr/>
+        </p:nvSpPr>
+        <p:spPr>
+          <a:xfrm>
+            <a:off x="640080" y="5806440"/>
+            <a:ext cx="10972800" cy="868680"/>
+          </a:xfrm>
+          <a:prstGeom prst="rect">
+            <a:avLst/>
+          </a:prstGeom>
+          <a:noFill/>
+        </p:spPr>
+        <p:txBody>
+          <a:bodyPr wrap="square">
+            <a:spAutoFit/>
+          </a:bodyPr>
+          <a:lstStyle/>
+          <a:p>
+            <a:pPr>
+              <a:spcAft>
+                <a:spcPts val="1400"/>
+              </a:spcAft>
+              <a:defRPr sz="1600">
+                <a:solidFill>
+                  <a:srgbClr val="75DFC8"/>
+                </a:solidFill>
+                <a:latin typeface="DejaVu Sans"/>
+              </a:defRPr>
+            </a:pPr>
+            <a:r>
+              <a:t>Tři otázky: původ dat → dopady feature → aktuální mechanismus finančního zdraví.</a:t>
             </a:r>
           </a:p>
         </p:txBody>
@@ -4519,7 +5376,85 @@
         </p:nvSpPr>
         <p:spPr>
           <a:xfrm>
-            <a:off x="548640" y="182880"/>
+            <a:off x="457200" y="164592"/>
+            <a:ext cx="10972800" cy="274320"/>
+          </a:xfrm>
+          <a:prstGeom prst="rect">
+            <a:avLst/>
+          </a:prstGeom>
+          <a:noFill/>
+        </p:spPr>
+        <p:txBody>
+          <a:bodyPr wrap="square">
+            <a:spAutoFit/>
+          </a:bodyPr>
+          <a:lstStyle/>
+          <a:p>
+            <a:pPr>
+              <a:spcAft>
+                <a:spcPts val="1400"/>
+              </a:spcAft>
+              <a:defRPr sz="1000">
+                <a:solidFill>
+                  <a:srgbClr val="A9BBD6"/>
+                </a:solidFill>
+                <a:latin typeface="DejaVu Sans"/>
+              </a:defRPr>
+            </a:pPr>
+            <a:r>
+              <a:t>LLM MEMORY LAB · 10/12 · MODELOVÁ BANKOVNÍ PLATFORMA</a:t>
+            </a:r>
+          </a:p>
+        </p:txBody>
+      </p:sp>
+      <p:sp>
+        <p:nvSpPr>
+          <p:cNvPr id="3" name="TextBox 2"/>
+          <p:cNvSpPr txBox="1"/>
+          <p:nvPr/>
+        </p:nvSpPr>
+        <p:spPr>
+          <a:xfrm>
+            <a:off x="457200" y="566928"/>
+            <a:ext cx="10972800" cy="457200"/>
+          </a:xfrm>
+          <a:prstGeom prst="rect">
+            <a:avLst/>
+          </a:prstGeom>
+          <a:noFill/>
+        </p:spPr>
+        <p:txBody>
+          <a:bodyPr wrap="square">
+            <a:spAutoFit/>
+          </a:bodyPr>
+          <a:lstStyle/>
+          <a:p>
+            <a:pPr>
+              <a:spcAft>
+                <a:spcPts val="1400"/>
+              </a:spcAft>
+              <a:defRPr sz="2700">
+                <a:solidFill>
+                  <a:srgbClr val="F0F4FF"/>
+                </a:solidFill>
+                <a:latin typeface="DejaVu Sans"/>
+              </a:defRPr>
+            </a:pPr>
+            <a:r>
+              <a:t>Jak ověřit současný mechanismus?</a:t>
+            </a:r>
+          </a:p>
+        </p:txBody>
+      </p:sp>
+      <p:sp>
+        <p:nvSpPr>
+          <p:cNvPr id="4" name="TextBox 3"/>
+          <p:cNvSpPr txBox="1"/>
+          <p:nvPr/>
+        </p:nvSpPr>
+        <p:spPr>
+          <a:xfrm>
+            <a:off x="457200" y="1060704"/>
             <a:ext cx="10972800" cy="365760"/>
           </a:xfrm>
           <a:prstGeom prst="rect">
@@ -4537,200 +5472,43 @@
               <a:spcAft>
                 <a:spcPts val="1400"/>
               </a:spcAft>
-              <a:defRPr sz="1200">
-                <a:solidFill>
-                  <a:srgbClr val="A9BBD6"/>
+              <a:defRPr sz="1600">
+                <a:solidFill>
+                  <a:srgbClr val="75DFC8"/>
                 </a:solidFill>
                 <a:latin typeface="DejaVu Sans"/>
               </a:defRPr>
             </a:pPr>
             <a:r>
-              <a:t>LLM MEMORY LAB · 10/12</a:t>
-            </a:r>
-          </a:p>
-        </p:txBody>
-      </p:sp>
-      <p:sp>
-        <p:nvSpPr>
-          <p:cNvPr id="3" name="TextBox 2"/>
-          <p:cNvSpPr txBox="1"/>
+              <a:t>Registr platnosti + implementace + vstupy výpočtu</a:t>
+            </a:r>
+          </a:p>
+        </p:txBody>
+      </p:sp>
+      <p:pic>
+        <p:nvPicPr>
+          <p:cNvPr id="5" name="Picture 4" descr="bank-health-evidence.png"/>
+          <p:cNvPicPr>
+            <a:picLocks noChangeAspect="1"/>
+          </p:cNvPicPr>
           <p:nvPr/>
-        </p:nvSpPr>
+        </p:nvPicPr>
+        <p:blipFill>
+          <a:blip r:embed="rId2"/>
+          <a:stretch>
+            <a:fillRect/>
+          </a:stretch>
+        </p:blipFill>
         <p:spPr>
           <a:xfrm>
-            <a:off x="548640" y="731520"/>
-            <a:ext cx="10972800" cy="1005840"/>
+            <a:off x="457200" y="1508760"/>
+            <a:ext cx="11247120" cy="5303520"/>
           </a:xfrm>
           <a:prstGeom prst="rect">
             <a:avLst/>
           </a:prstGeom>
-          <a:noFill/>
         </p:spPr>
-        <p:txBody>
-          <a:bodyPr wrap="square">
-            <a:spAutoFit/>
-          </a:bodyPr>
-          <a:lstStyle/>
-          <a:p>
-            <a:pPr>
-              <a:spcAft>
-                <a:spcPts val="1400"/>
-              </a:spcAft>
-              <a:defRPr sz="3200">
-                <a:solidFill>
-                  <a:srgbClr val="F0F4FF"/>
-                </a:solidFill>
-                <a:latin typeface="DejaVu Sans"/>
-              </a:defRPr>
-            </a:pPr>
-            <a:r>
-              <a:t>Hybrid: oddělte text, stav a vazby</a:t>
-            </a:r>
-          </a:p>
-        </p:txBody>
-      </p:sp>
-      <p:sp>
-        <p:nvSpPr>
-          <p:cNvPr id="4" name="TextBox 3"/>
-          <p:cNvSpPr txBox="1"/>
-          <p:nvPr/>
-        </p:nvSpPr>
-        <p:spPr>
-          <a:xfrm>
-            <a:off x="548640" y="1783080"/>
-            <a:ext cx="10972800" cy="548640"/>
-          </a:xfrm>
-          <a:prstGeom prst="rect">
-            <a:avLst/>
-          </a:prstGeom>
-          <a:noFill/>
-        </p:spPr>
-        <p:txBody>
-          <a:bodyPr wrap="square">
-            <a:spAutoFit/>
-          </a:bodyPr>
-          <a:lstStyle/>
-          <a:p>
-            <a:pPr>
-              <a:spcAft>
-                <a:spcPts val="1400"/>
-              </a:spcAft>
-              <a:defRPr sz="2100">
-                <a:solidFill>
-                  <a:srgbClr val="75DFC8"/>
-                </a:solidFill>
-                <a:latin typeface="DejaVu Sans"/>
-              </a:defRPr>
-            </a:pPr>
-            <a:r>
-              <a:t>Orchestrace je část ceny</a:t>
-            </a:r>
-          </a:p>
-        </p:txBody>
-      </p:sp>
-      <p:sp>
-        <p:nvSpPr>
-          <p:cNvPr id="5" name="TextBox 4"/>
-          <p:cNvSpPr txBox="1"/>
-          <p:nvPr/>
-        </p:nvSpPr>
-        <p:spPr>
-          <a:xfrm>
-            <a:off x="640080" y="2560320"/>
-            <a:ext cx="10972800" cy="3931920"/>
-          </a:xfrm>
-          <a:prstGeom prst="rect">
-            <a:avLst/>
-          </a:prstGeom>
-          <a:noFill/>
-        </p:spPr>
-        <p:txBody>
-          <a:bodyPr wrap="square">
-            <a:spAutoFit/>
-          </a:bodyPr>
-          <a:lstStyle/>
-          <a:p>
-            <a:pPr>
-              <a:spcAft>
-                <a:spcPts val="1400"/>
-              </a:spcAft>
-              <a:defRPr sz="2300">
-                <a:solidFill>
-                  <a:srgbClr val="F0F4FF"/>
-                </a:solidFill>
-                <a:latin typeface="DejaVu Sans"/>
-              </a:defRPr>
-            </a:pPr>
-            <a:r>
-              <a:t>• Ulož událost se source_id, entity_id, valid_from/to a autoritou.</a:t>
-            </a:r>
-          </a:p>
-          <a:p>
-            <a:pPr>
-              <a:spcAft>
-                <a:spcPts val="1400"/>
-              </a:spcAft>
-              <a:defRPr sz="2300">
-                <a:solidFill>
-                  <a:srgbClr val="F0F4FF"/>
-                </a:solidFill>
-                <a:latin typeface="DejaVu Sans"/>
-              </a:defRPr>
-            </a:pPr>
-            <a:r>
-              <a:t>• SQL / JSON: aktuální stav; graf: vztahy; vektory: epizody.</a:t>
-            </a:r>
-          </a:p>
-          <a:p>
-            <a:pPr>
-              <a:spcAft>
-                <a:spcPts val="1400"/>
-              </a:spcAft>
-              <a:defRPr sz="2300">
-                <a:solidFill>
-                  <a:srgbClr val="F0F4FF"/>
-                </a:solidFill>
-                <a:latin typeface="DejaVu Sans"/>
-              </a:defRPr>
-            </a:pPr>
-            <a:r>
-              <a:t>• Dotaz → intent + entity → retrieval → deduplikace → budget.</a:t>
-            </a:r>
-          </a:p>
-          <a:p>
-            <a:pPr>
-              <a:spcAft>
-                <a:spcPts val="1400"/>
-              </a:spcAft>
-              <a:defRPr sz="2300">
-                <a:solidFill>
-                  <a:srgbClr val="F0F4FF"/>
-                </a:solidFill>
-                <a:latin typeface="DejaVu Sans"/>
-              </a:defRPr>
-            </a:pPr>
-            <a:r>
-              <a:t>• Ke každému důkazu připoj zdroj, čas a verzi.</a:t>
-            </a:r>
-          </a:p>
-          <a:p>
-            <a:pPr>
-              <a:spcAft>
-                <a:spcPts val="1400"/>
-              </a:spcAft>
-              <a:defRPr sz="2300">
-                <a:solidFill>
-                  <a:srgbClr val="F0F4FF"/>
-                </a:solidFill>
-                <a:latin typeface="DejaVu Sans"/>
-              </a:defRPr>
-            </a:pPr>
-            <a:r>
-              <a:t>• Při konfliktu zdrojů ukaž nejistotu, nedělej tichý overwrite.</a:t>
-            </a:r>
-          </a:p>
-        </p:txBody>
-      </p:sp>
+      </p:pic>
     </p:spTree>
   </p:cSld>
   <p:clrMapOvr>
@@ -4830,7 +5608,7 @@
               </a:defRPr>
             </a:pPr>
             <a:r>
-              <a:t>Cvičení: návrh paměti pro vašeho agenta</a:t>
+              <a:t>Cvičení: agent pro trading platformu</a:t>
             </a:r>
           </a:p>
         </p:txBody>
@@ -4869,7 +5647,7 @@
               </a:defRPr>
             </a:pPr>
             <a:r>
-              <a:t>Dvě minuty ve dvojicích</a:t>
+              <a:t>Dvě minuty návrhu + dvě krátké odpovědi</a:t>
             </a:r>
           </a:p>
         </p:txBody>
@@ -4883,7 +5661,7 @@
         <p:spPr>
           <a:xfrm>
             <a:off x="640080" y="2560320"/>
-            <a:ext cx="10972800" cy="3931920"/>
+            <a:ext cx="10972800" cy="3200400"/>
           </a:xfrm>
           <a:prstGeom prst="rect">
             <a:avLst/>
@@ -4900,7 +5678,7 @@
               <a:spcAft>
                 <a:spcPts val="1400"/>
               </a:spcAft>
-              <a:defRPr sz="2300">
+              <a:defRPr sz="2000">
                 <a:solidFill>
                   <a:srgbClr val="F0F4FF"/>
                 </a:solidFill>
@@ -4908,7 +5686,7 @@
               </a:defRPr>
             </a:pPr>
             <a:r>
-              <a:t>• Agent si pamatuje preference, incidenty a vlastníky služeb.</a:t>
+              <a:t>• Agent má vysvětlit původ dat reportu, dopady feature a aktuální mechanismus skóre.</a:t>
             </a:r>
           </a:p>
           <a:p>
@@ -4916,7 +5694,7 @@
               <a:spcAft>
                 <a:spcPts val="1400"/>
               </a:spcAft>
-              <a:defRPr sz="2300">
+              <a:defRPr sz="2000">
                 <a:solidFill>
                   <a:srgbClr val="F0F4FF"/>
                 </a:solidFill>
@@ -4924,7 +5702,7 @@
               </a:defRPr>
             </a:pPr>
             <a:r>
-              <a:t>• Má vracet nejvýše 1 000 tokenů důkazů.</a:t>
+              <a:t>• Pro každou otázku určete potřebné důkazy a způsob jejich vybavení.</a:t>
             </a:r>
           </a:p>
           <a:p>
@@ -4932,7 +5710,7 @@
               <a:spcAft>
                 <a:spcPts val="1400"/>
               </a:spcAft>
-              <a:defRPr sz="2300">
+              <a:defRPr sz="2000">
                 <a:solidFill>
                   <a:srgbClr val="F0F4FF"/>
                 </a:solidFill>
@@ -4940,7 +5718,7 @@
               </a:defRPr>
             </a:pPr>
             <a:r>
-              <a:t>• Navrhněte zápis, retrieval a chování při změně vlastníka.</a:t>
+              <a:t>• Přidejte test: nový draft nesmí přepsat platné nasazené pravidlo.</a:t>
             </a:r>
           </a:p>
           <a:p>
@@ -4948,7 +5726,7 @@
               <a:spcAft>
                 <a:spcPts val="1400"/>
               </a:spcAft>
-              <a:defRPr sz="2300">
+              <a:defRPr sz="2000">
                 <a:solidFill>
                   <a:srgbClr val="F0F4FF"/>
                 </a:solidFill>
@@ -4956,7 +5734,46 @@
               </a:defRPr>
             </a:pPr>
             <a:r>
-              <a:t>• Jakým dotazem zjistíte, že návrh selhal?</a:t>
+              <a:t>• Agent dostane nejvýše 1 000 tokenů podkladů; co zachováte a co vypustíte?</a:t>
+            </a:r>
+          </a:p>
+        </p:txBody>
+      </p:sp>
+      <p:sp>
+        <p:nvSpPr>
+          <p:cNvPr id="6" name="TextBox 5"/>
+          <p:cNvSpPr txBox="1"/>
+          <p:nvPr/>
+        </p:nvSpPr>
+        <p:spPr>
+          <a:xfrm>
+            <a:off x="640080" y="5806440"/>
+            <a:ext cx="10972800" cy="868680"/>
+          </a:xfrm>
+          <a:prstGeom prst="rect">
+            <a:avLst/>
+          </a:prstGeom>
+          <a:noFill/>
+        </p:spPr>
+        <p:txBody>
+          <a:bodyPr wrap="square">
+            <a:spAutoFit/>
+          </a:bodyPr>
+          <a:lstStyle/>
+          <a:p>
+            <a:pPr>
+              <a:spcAft>
+                <a:spcPts val="1400"/>
+              </a:spcAft>
+              <a:defRPr sz="1600">
+                <a:solidFill>
+                  <a:srgbClr val="75DFC8"/>
+                </a:solidFill>
+                <a:latin typeface="DejaVu Sans"/>
+              </a:defRPr>
+            </a:pPr>
+            <a:r>
+              <a:t>Pomůcka: lineage a dopady v grafu; platnost v registru; popisy a podobné incidenty v textu.</a:t>
             </a:r>
           </a:p>
         </p:txBody>
@@ -5060,7 +5877,7 @@
               </a:defRPr>
             </a:pPr>
             <a:r>
-              <a:t>Rozhodnutí a další experiment</a:t>
+              <a:t>Co si odnést do dalšího návrhu?</a:t>
             </a:r>
           </a:p>
         </p:txBody>
@@ -5099,7 +5916,7 @@
               </a:defRPr>
             </a:pPr>
             <a:r>
-              <a:t>Začněte otázkami, které agent musí zvládnout</a:t>
+              <a:t>Nejdřív otázky a důkazy, potom nástroj</a:t>
             </a:r>
           </a:p>
         </p:txBody>
@@ -5113,7 +5930,7 @@
         <p:spPr>
           <a:xfrm>
             <a:off x="640080" y="2560320"/>
-            <a:ext cx="10972800" cy="3931920"/>
+            <a:ext cx="10972800" cy="3200400"/>
           </a:xfrm>
           <a:prstGeom prst="rect">
             <a:avLst/>
@@ -5130,7 +5947,7 @@
               <a:spcAft>
                 <a:spcPts val="1400"/>
               </a:spcAft>
-              <a:defRPr sz="2300">
+              <a:defRPr sz="2000">
                 <a:solidFill>
                   <a:srgbClr val="F0F4FF"/>
                 </a:solidFill>
@@ -5138,7 +5955,7 @@
               </a:defRPr>
             </a:pPr>
             <a:r>
-              <a:t>• Podobné zkušenosti → textové / vektorové hledání.</a:t>
+              <a:t>• Podobná zkušenost: začněte hledáním v textu nebo vektorech.</a:t>
             </a:r>
           </a:p>
           <a:p>
@@ -5146,7 +5963,7 @@
               <a:spcAft>
                 <a:spcPts val="1400"/>
               </a:spcAft>
-              <a:defRPr sz="2300">
+              <a:defRPr sz="2000">
                 <a:solidFill>
                   <a:srgbClr val="F0F4FF"/>
                 </a:solidFill>
@@ -5154,7 +5971,7 @@
               </a:defRPr>
             </a:pPr>
             <a:r>
-              <a:t>• Přesná fakta a aktuální hodnoty → SQL / JSON + časové filtry.</a:t>
+              <a:t>• Přesná hodnota: použijte pojmenovaný stav a kontrolu platnosti.</a:t>
             </a:r>
           </a:p>
           <a:p>
@@ -5162,7 +5979,7 @@
               <a:spcAft>
                 <a:spcPts val="1400"/>
               </a:spcAft>
-              <a:defRPr sz="2300">
+              <a:defRPr sz="2000">
                 <a:solidFill>
                   <a:srgbClr val="F0F4FF"/>
                 </a:solidFill>
@@ -5170,7 +5987,7 @@
               </a:defRPr>
             </a:pPr>
             <a:r>
-              <a:t>• Více vazeb a dopady → graf, pokud máte kvalitní entity a hrany.</a:t>
+              <a:t>• Návaznost objektů: použijte explicitní vztahy v grafu nebo tabulkové joiny.</a:t>
             </a:r>
           </a:p>
           <a:p>
@@ -5178,7 +5995,7 @@
               <a:spcAft>
                 <a:spcPts val="1400"/>
               </a:spcAft>
-              <a:defRPr sz="2300">
+              <a:defRPr sz="2000">
                 <a:solidFill>
                   <a:srgbClr val="F0F4FF"/>
                 </a:solidFill>
@@ -5186,23 +6003,46 @@
               </a:defRPr>
             </a:pPr>
             <a:r>
-              <a:t>• Kombinujte jen tam, kde testy ukážou přínos.</a:t>
-            </a:r>
-          </a:p>
+              <a:t>• Kombinaci ověřte na vlastních úlohách: správnost, délka kontextu a cena změn.</a:t>
+            </a:r>
+          </a:p>
+        </p:txBody>
+      </p:sp>
+      <p:sp>
+        <p:nvSpPr>
+          <p:cNvPr id="6" name="TextBox 5"/>
+          <p:cNvSpPr txBox="1"/>
+          <p:nvPr/>
+        </p:nvSpPr>
+        <p:spPr>
+          <a:xfrm>
+            <a:off x="640080" y="5806440"/>
+            <a:ext cx="10972800" cy="868680"/>
+          </a:xfrm>
+          <a:prstGeom prst="rect">
+            <a:avLst/>
+          </a:prstGeom>
+          <a:noFill/>
+        </p:spPr>
+        <p:txBody>
+          <a:bodyPr wrap="square">
+            <a:spAutoFit/>
+          </a:bodyPr>
+          <a:lstStyle/>
           <a:p>
             <a:pPr>
               <a:spcAft>
                 <a:spcPts val="1400"/>
               </a:spcAft>
-              <a:defRPr sz="2300">
-                <a:solidFill>
-                  <a:srgbClr val="F0F4FF"/>
+              <a:defRPr sz="1600">
+                <a:solidFill>
+                  <a:srgbClr val="75DFC8"/>
                 </a:solidFill>
                 <a:latin typeface="DejaVu Sans"/>
               </a:defRPr>
             </a:pPr>
             <a:r>
-              <a:t>• Produkčně měřte odpovědi, tokeny, p95, ingest a cenu aktualizací.</a:t>
+              <a:t>Další krok: skutečný report, jedna navržená feature a platný registry mechanismů z vašeho repozitáře.</a:t>
             </a:r>
           </a:p>
         </p:txBody>
@@ -5306,7 +6146,7 @@
               </a:defRPr>
             </a:pPr>
             <a:r>
-              <a:t>Tři různé rozpočty</a:t>
+              <a:t>Co vlastně šetříme?</a:t>
             </a:r>
           </a:p>
         </p:txBody>
@@ -5345,7 +6185,7 @@
               </a:defRPr>
             </a:pPr>
             <a:r>
-              <a:t>Nezaměňujme kontext, úložiště a RAM</a:t>
+              <a:t>Kontext modelu, úložiště a RAM jsou různé věci</a:t>
             </a:r>
           </a:p>
         </p:txBody>
@@ -5359,7 +6199,7 @@
         <p:spPr>
           <a:xfrm>
             <a:off x="640080" y="2560320"/>
-            <a:ext cx="10972800" cy="3931920"/>
+            <a:ext cx="10972800" cy="3200400"/>
           </a:xfrm>
           <a:prstGeom prst="rect">
             <a:avLst/>
@@ -5376,7 +6216,7 @@
               <a:spcAft>
                 <a:spcPts val="1400"/>
               </a:spcAft>
-              <a:defRPr sz="2300">
+              <a:defRPr sz="2000">
                 <a:solidFill>
                   <a:srgbClr val="F0F4FF"/>
                 </a:solidFill>
@@ -5384,7 +6224,7 @@
               </a:defRPr>
             </a:pPr>
             <a:r>
-              <a:t>• Kontext LLM: tokeny vybraných důkazů a instrukcí.</a:t>
+              <a:t>• Kontext je text poslaný modelu; delší zadání spotřebuje více tokenů.</a:t>
             </a:r>
           </a:p>
           <a:p>
@@ -5392,7 +6232,7 @@
               <a:spcAft>
                 <a:spcPts val="1400"/>
               </a:spcAft>
-              <a:defRPr sz="2300">
+              <a:defRPr sz="2000">
                 <a:solidFill>
                   <a:srgbClr val="F0F4FF"/>
                 </a:solidFill>
@@ -5400,7 +6240,7 @@
               </a:defRPr>
             </a:pPr>
             <a:r>
-              <a:t>• Úložiště: původní text + metadata + embeddingy / hrany.</a:t>
+              <a:t>• Úložiště drží všechny zdroje a indexy, i když je model právě nevidí.</a:t>
             </a:r>
           </a:p>
           <a:p>
@@ -5408,7 +6248,7 @@
               <a:spcAft>
                 <a:spcPts val="1400"/>
               </a:spcAft>
-              <a:defRPr sz="2300">
+              <a:defRPr sz="2000">
                 <a:solidFill>
                   <a:srgbClr val="F0F4FF"/>
                 </a:solidFill>
@@ -5416,7 +6256,7 @@
               </a:defRPr>
             </a:pPr>
             <a:r>
-              <a:t>• RAM a latence: index, cache, retrieval, případně model.</a:t>
+              <a:t>• RAM je pracovní paměť běžícího systému; latence je čas do výsledku.</a:t>
             </a:r>
           </a:p>
           <a:p>
@@ -5424,7 +6264,7 @@
               <a:spcAft>
                 <a:spcPts val="1400"/>
               </a:spcAft>
-              <a:defRPr sz="2300">
+              <a:defRPr sz="2000">
                 <a:solidFill>
                   <a:srgbClr val="F0F4FF"/>
                 </a:solidFill>
@@ -5432,7 +6272,46 @@
               </a:defRPr>
             </a:pPr>
             <a:r>
-              <a:t>• Menší retrieval neznamená automaticky správnější odpověď.</a:t>
+              <a:t>• V ukázce měříme délku vybraného textu v bajtech a úplnost důkazů.</a:t>
+            </a:r>
+          </a:p>
+        </p:txBody>
+      </p:sp>
+      <p:sp>
+        <p:nvSpPr>
+          <p:cNvPr id="6" name="TextBox 5"/>
+          <p:cNvSpPr txBox="1"/>
+          <p:nvPr/>
+        </p:nvSpPr>
+        <p:spPr>
+          <a:xfrm>
+            <a:off x="640080" y="5806440"/>
+            <a:ext cx="10972800" cy="868680"/>
+          </a:xfrm>
+          <a:prstGeom prst="rect">
+            <a:avLst/>
+          </a:prstGeom>
+          <a:noFill/>
+        </p:spPr>
+        <p:txBody>
+          <a:bodyPr wrap="square">
+            <a:spAutoFit/>
+          </a:bodyPr>
+          <a:lstStyle/>
+          <a:p>
+            <a:pPr>
+              <a:spcAft>
+                <a:spcPts val="1400"/>
+              </a:spcAft>
+              <a:defRPr sz="1600">
+                <a:solidFill>
+                  <a:srgbClr val="75DFC8"/>
+                </a:solidFill>
+                <a:latin typeface="DejaVu Sans"/>
+              </a:defRPr>
+            </a:pPr>
+            <a:r>
+              <a:t>Archiv dokumentů zůstává v úložišti; model má dostat jen ověřené podklady ke konkrétnímu reportu.</a:t>
             </a:r>
           </a:p>
         </p:txBody>
@@ -5536,7 +6415,7 @@
               </a:defRPr>
             </a:pPr>
             <a:r>
-              <a:t>Menu struktur</a:t>
+              <a:t>Pět způsobů uložení</a:t>
             </a:r>
           </a:p>
         </p:txBody>
@@ -5575,7 +6454,7 @@
               </a:defRPr>
             </a:pPr>
             <a:r>
-              <a:t>Paměť není jen databáze</a:t>
+              <a:t>Každá struktura zachovává jiný druh informace</a:t>
             </a:r>
           </a:p>
         </p:txBody>
@@ -5589,7 +6468,7 @@
         <p:spPr>
           <a:xfrm>
             <a:off x="640080" y="2560320"/>
-            <a:ext cx="10972800" cy="3931920"/>
+            <a:ext cx="10972800" cy="3200400"/>
           </a:xfrm>
           <a:prstGeom prst="rect">
             <a:avLst/>
@@ -5606,7 +6485,7 @@
               <a:spcAft>
                 <a:spcPts val="1400"/>
               </a:spcAft>
-              <a:defRPr sz="2300">
+              <a:defRPr sz="2000">
                 <a:solidFill>
                   <a:srgbClr val="F0F4FF"/>
                 </a:solidFill>
@@ -5614,7 +6493,7 @@
               </a:defRPr>
             </a:pPr>
             <a:r>
-              <a:t>• Okno historie: přesné nedávné události; staré informace vypadnou.</a:t>
+              <a:t>• Historie uchová původní zprávy; souhrn je zkrátí, ale může ztratit výjimku.</a:t>
             </a:r>
           </a:p>
           <a:p>
@@ -5622,7 +6501,7 @@
               <a:spcAft>
                 <a:spcPts val="1400"/>
               </a:spcAft>
-              <a:defRPr sz="2300">
+              <a:defRPr sz="2000">
                 <a:solidFill>
                   <a:srgbClr val="F0F4FF"/>
                 </a:solidFill>
@@ -5630,7 +6509,7 @@
               </a:defRPr>
             </a:pPr>
             <a:r>
-              <a:t>• Summary: krátký přehled; při kompresi může zmizet podmínka či zdroj.</a:t>
+              <a:t>• JSON nebo SQL drží přesné hodnoty, například jazyk uživatele a verzi vlastníka.</a:t>
             </a:r>
           </a:p>
           <a:p>
@@ -5638,7 +6517,7 @@
               <a:spcAft>
                 <a:spcPts val="1400"/>
               </a:spcAft>
-              <a:defRPr sz="2300">
+              <a:defRPr sz="2000">
                 <a:solidFill>
                   <a:srgbClr val="F0F4FF"/>
                 </a:solidFill>
@@ -5646,7 +6525,7 @@
               </a:defRPr>
             </a:pPr>
             <a:r>
-              <a:t>• JSON / SQL: aktuální stav, preference, verze a přesné filtry.</a:t>
+              <a:t>• Textové epizody popisují zkušenosti; vektory pomohou najít podobný záznam.</a:t>
             </a:r>
           </a:p>
           <a:p>
@@ -5654,7 +6533,7 @@
               <a:spcAft>
                 <a:spcPts val="1400"/>
               </a:spcAft>
-              <a:defRPr sz="2300">
+              <a:defRPr sz="2000">
                 <a:solidFill>
                   <a:srgbClr val="F0F4FF"/>
                 </a:solidFill>
@@ -5662,23 +6541,46 @@
               </a:defRPr>
             </a:pPr>
             <a:r>
-              <a:t>• Episody + vektory: podobné zkušenosti a neformální text.</a:t>
-            </a:r>
-          </a:p>
+              <a:t>• Knowledge Graph propojuje entity vztahy, například služba → databáze → tým.</a:t>
+            </a:r>
+          </a:p>
+        </p:txBody>
+      </p:sp>
+      <p:sp>
+        <p:nvSpPr>
+          <p:cNvPr id="6" name="TextBox 5"/>
+          <p:cNvSpPr txBox="1"/>
+          <p:nvPr/>
+        </p:nvSpPr>
+        <p:spPr>
+          <a:xfrm>
+            <a:off x="640080" y="5806440"/>
+            <a:ext cx="10972800" cy="868680"/>
+          </a:xfrm>
+          <a:prstGeom prst="rect">
+            <a:avLst/>
+          </a:prstGeom>
+          <a:noFill/>
+        </p:spPr>
+        <p:txBody>
+          <a:bodyPr wrap="square">
+            <a:spAutoFit/>
+          </a:bodyPr>
+          <a:lstStyle/>
           <a:p>
             <a:pPr>
               <a:spcAft>
                 <a:spcPts val="1400"/>
               </a:spcAft>
-              <a:defRPr sz="2300">
-                <a:solidFill>
-                  <a:srgbClr val="F0F4FF"/>
+              <a:defRPr sz="1600">
+                <a:solidFill>
+                  <a:srgbClr val="75DFC8"/>
                 </a:solidFill>
                 <a:latin typeface="DejaVu Sans"/>
               </a:defRPr>
             </a:pPr>
             <a:r>
-              <a:t>• Knowledge Graph: entity, typované vztahy, cesty a provenience.</a:t>
+              <a:t>Profil klienta = přesný stav; incident reportu = zkušenost; report → výpočet → datový zdroj = vztahy.</a:t>
             </a:r>
           </a:p>
         </p:txBody>
@@ -5782,7 +6684,7 @@
               </a:defRPr>
             </a:pPr>
             <a:r>
-              <a:t>Stejná data, jiné otázky</a:t>
+              <a:t>Tři otázky z podpory tradingu</a:t>
             </a:r>
           </a:p>
         </p:txBody>
@@ -5821,7 +6723,7 @@
               </a:defRPr>
             </a:pPr>
             <a:r>
-              <a:t>Tři provozní úlohy</a:t>
+              <a:t>Každá otázka potřebuje jiný pohled na platformu</a:t>
             </a:r>
           </a:p>
         </p:txBody>
@@ -5835,7 +6737,7 @@
         <p:spPr>
           <a:xfrm>
             <a:off x="640080" y="2560320"/>
-            <a:ext cx="10972800" cy="3931920"/>
+            <a:ext cx="10972800" cy="3200400"/>
           </a:xfrm>
           <a:prstGeom prst="rect">
             <a:avLst/>
@@ -5852,7 +6754,7 @@
               <a:spcAft>
                 <a:spcPts val="1400"/>
               </a:spcAft>
-              <a:defRPr sz="2300">
+              <a:defRPr sz="2000">
                 <a:solidFill>
                   <a:srgbClr val="F0F4FF"/>
                 </a:solidFill>
@@ -5860,7 +6762,7 @@
               </a:defRPr>
             </a:pPr>
             <a:r>
-              <a:t>• A • Jak se řešil podobný connection-pool timeout?</a:t>
+              <a:t>• A: „Odkud se berou data pro týdenní report?“ Sledujeme datovou lineage.</a:t>
             </a:r>
           </a:p>
           <a:p>
@@ -5868,7 +6770,7 @@
               <a:spcAft>
                 <a:spcPts val="1400"/>
               </a:spcAft>
-              <a:defRPr sz="2300">
+              <a:defRPr sz="2000">
                 <a:solidFill>
                   <a:srgbClr val="F0F4FF"/>
                 </a:solidFill>
@@ -5876,7 +6778,7 @@
               </a:defRPr>
             </a:pPr>
             <a:r>
-              <a:t>• B • Na čem svc-0 závisí a který tým eskalovat?</a:t>
+              <a:t>• B: „Co ovlivní feature what-if margin?“ Hledáme přímé i nepřímé volající.</a:t>
             </a:r>
           </a:p>
           <a:p>
@@ -5884,7 +6786,7 @@
               <a:spcAft>
                 <a:spcPts val="1400"/>
               </a:spcAft>
-              <a:defRPr sz="2300">
+              <a:defRPr sz="2000">
                 <a:solidFill>
                   <a:srgbClr val="F0F4FF"/>
                 </a:solidFill>
@@ -5892,7 +6794,7 @@
               </a:defRPr>
             </a:pPr>
             <a:r>
-              <a:t>• C • Kdo je aktuální vlastník svc-0 po migraci?</a:t>
+              <a:t>• C: „Jaký je současný výpočet finančního zdraví?“ Potřebujeme kód i platnou konfiguraci.</a:t>
             </a:r>
           </a:p>
           <a:p>
@@ -5900,7 +6802,7 @@
               <a:spcAft>
                 <a:spcPts val="1400"/>
               </a:spcAft>
-              <a:defRPr sz="2300">
+              <a:defRPr sz="2000">
                 <a:solidFill>
                   <a:srgbClr val="F0F4FF"/>
                 </a:solidFill>
@@ -5908,7 +6810,46 @@
               </a:defRPr>
             </a:pPr>
             <a:r>
-              <a:t>• Tipněte si: vektor, graf, nebo přesný stav?</a:t>
+              <a:t>• Ve dvojici tipněte: jaký důkaz by vám k odpovědi nestačil?</a:t>
+            </a:r>
+          </a:p>
+        </p:txBody>
+      </p:sp>
+      <p:sp>
+        <p:nvSpPr>
+          <p:cNvPr id="6" name="TextBox 5"/>
+          <p:cNvSpPr txBox="1"/>
+          <p:nvPr/>
+        </p:nvSpPr>
+        <p:spPr>
+          <a:xfrm>
+            <a:off x="640080" y="5806440"/>
+            <a:ext cx="10972800" cy="868680"/>
+          </a:xfrm>
+          <a:prstGeom prst="rect">
+            <a:avLst/>
+          </a:prstGeom>
+          <a:noFill/>
+        </p:spPr>
+        <p:txBody>
+          <a:bodyPr wrap="square">
+            <a:spAutoFit/>
+          </a:bodyPr>
+          <a:lstStyle/>
+          <a:p>
+            <a:pPr>
+              <a:spcAft>
+                <a:spcPts val="1400"/>
+              </a:spcAft>
+              <a:defRPr sz="1600">
+                <a:solidFill>
+                  <a:srgbClr val="75DFC8"/>
+                </a:solidFill>
+                <a:latin typeface="DejaVu Sans"/>
+              </a:defRPr>
+            </a:pPr>
+            <a:r>
+              <a:t>Lineage = cesta původu dat. Dopad feature = cesta od měněné funkce k jejím uživatelům.</a:t>
             </a:r>
           </a:p>
         </p:txBody>
@@ -5947,7 +6888,85 @@
         </p:nvSpPr>
         <p:spPr>
           <a:xfrm>
-            <a:off x="548640" y="182880"/>
+            <a:off x="457200" y="164592"/>
+            <a:ext cx="10972800" cy="274320"/>
+          </a:xfrm>
+          <a:prstGeom prst="rect">
+            <a:avLst/>
+          </a:prstGeom>
+          <a:noFill/>
+        </p:spPr>
+        <p:txBody>
+          <a:bodyPr wrap="square">
+            <a:spAutoFit/>
+          </a:bodyPr>
+          <a:lstStyle/>
+          <a:p>
+            <a:pPr>
+              <a:spcAft>
+                <a:spcPts val="1400"/>
+              </a:spcAft>
+              <a:defRPr sz="1000">
+                <a:solidFill>
+                  <a:srgbClr val="A9BBD6"/>
+                </a:solidFill>
+                <a:latin typeface="DejaVu Sans"/>
+              </a:defRPr>
+            </a:pPr>
+            <a:r>
+              <a:t>LLM MEMORY LAB · 05/12 · MODELOVÁ BANKOVNÍ PLATFORMA</a:t>
+            </a:r>
+          </a:p>
+        </p:txBody>
+      </p:sp>
+      <p:sp>
+        <p:nvSpPr>
+          <p:cNvPr id="3" name="TextBox 2"/>
+          <p:cNvSpPr txBox="1"/>
+          <p:nvPr/>
+        </p:nvSpPr>
+        <p:spPr>
+          <a:xfrm>
+            <a:off x="457200" y="566928"/>
+            <a:ext cx="10972800" cy="457200"/>
+          </a:xfrm>
+          <a:prstGeom prst="rect">
+            <a:avLst/>
+          </a:prstGeom>
+          <a:noFill/>
+        </p:spPr>
+        <p:txBody>
+          <a:bodyPr wrap="square">
+            <a:spAutoFit/>
+          </a:bodyPr>
+          <a:lstStyle/>
+          <a:p>
+            <a:pPr>
+              <a:spcAft>
+                <a:spcPts val="1400"/>
+              </a:spcAft>
+              <a:defRPr sz="2700">
+                <a:solidFill>
+                  <a:srgbClr val="F0F4FF"/>
+                </a:solidFill>
+                <a:latin typeface="DejaVu Sans"/>
+              </a:defRPr>
+            </a:pPr>
+            <a:r>
+              <a:t>Vektory versus grafy: odkud jsou data?</a:t>
+            </a:r>
+          </a:p>
+        </p:txBody>
+      </p:sp>
+      <p:sp>
+        <p:nvSpPr>
+          <p:cNvPr id="4" name="TextBox 3"/>
+          <p:cNvSpPr txBox="1"/>
+          <p:nvPr/>
+        </p:nvSpPr>
+        <p:spPr>
+          <a:xfrm>
+            <a:off x="457200" y="1060704"/>
             <a:ext cx="10972800" cy="365760"/>
           </a:xfrm>
           <a:prstGeom prst="rect">
@@ -5965,200 +6984,43 @@
               <a:spcAft>
                 <a:spcPts val="1400"/>
               </a:spcAft>
-              <a:defRPr sz="1200">
-                <a:solidFill>
-                  <a:srgbClr val="A9BBD6"/>
+              <a:defRPr sz="1600">
+                <a:solidFill>
+                  <a:srgbClr val="75DFC8"/>
                 </a:solidFill>
                 <a:latin typeface="DejaVu Sans"/>
               </a:defRPr>
             </a:pPr>
             <a:r>
-              <a:t>LLM MEMORY LAB · 05/12</a:t>
-            </a:r>
-          </a:p>
-        </p:txBody>
-      </p:sp>
-      <p:sp>
-        <p:nvSpPr>
-          <p:cNvPr id="3" name="TextBox 2"/>
-          <p:cNvSpPr txBox="1"/>
+              <a:t>Postupně odhalte rozdíl mezi podobností a návazností</a:t>
+            </a:r>
+          </a:p>
+        </p:txBody>
+      </p:sp>
+      <p:pic>
+        <p:nvPicPr>
+          <p:cNvPr id="5" name="Picture 4" descr="bank-report-evidence.png"/>
+          <p:cNvPicPr>
+            <a:picLocks noChangeAspect="1"/>
+          </p:cNvPicPr>
           <p:nvPr/>
-        </p:nvSpPr>
+        </p:nvPicPr>
+        <p:blipFill>
+          <a:blip r:embed="rId2"/>
+          <a:stretch>
+            <a:fillRect/>
+          </a:stretch>
+        </p:blipFill>
         <p:spPr>
           <a:xfrm>
-            <a:off x="548640" y="731520"/>
-            <a:ext cx="10972800" cy="1005840"/>
+            <a:off x="457200" y="1508760"/>
+            <a:ext cx="11247120" cy="5303520"/>
           </a:xfrm>
           <a:prstGeom prst="rect">
             <a:avLst/>
           </a:prstGeom>
-          <a:noFill/>
         </p:spPr>
-        <p:txBody>
-          <a:bodyPr wrap="square">
-            <a:spAutoFit/>
-          </a:bodyPr>
-          <a:lstStyle/>
-          <a:p>
-            <a:pPr>
-              <a:spcAft>
-                <a:spcPts val="1400"/>
-              </a:spcAft>
-              <a:defRPr sz="3200">
-                <a:solidFill>
-                  <a:srgbClr val="F0F4FF"/>
-                </a:solidFill>
-                <a:latin typeface="DejaVu Sans"/>
-              </a:defRPr>
-            </a:pPr>
-            <a:r>
-              <a:t>Knowledge Graph × vektorový index</a:t>
-            </a:r>
-          </a:p>
-        </p:txBody>
-      </p:sp>
-      <p:sp>
-        <p:nvSpPr>
-          <p:cNvPr id="4" name="TextBox 3"/>
-          <p:cNvSpPr txBox="1"/>
-          <p:nvPr/>
-        </p:nvSpPr>
-        <p:spPr>
-          <a:xfrm>
-            <a:off x="548640" y="1783080"/>
-            <a:ext cx="10972800" cy="548640"/>
-          </a:xfrm>
-          <a:prstGeom prst="rect">
-            <a:avLst/>
-          </a:prstGeom>
-          <a:noFill/>
-        </p:spPr>
-        <p:txBody>
-          <a:bodyPr wrap="square">
-            <a:spAutoFit/>
-          </a:bodyPr>
-          <a:lstStyle/>
-          <a:p>
-            <a:pPr>
-              <a:spcAft>
-                <a:spcPts val="1400"/>
-              </a:spcAft>
-              <a:defRPr sz="2100">
-                <a:solidFill>
-                  <a:srgbClr val="75DFC8"/>
-                </a:solidFill>
-                <a:latin typeface="DejaVu Sans"/>
-              </a:defRPr>
-            </a:pPr>
-            <a:r>
-              <a:t>Podobnost není vztah</a:t>
-            </a:r>
-          </a:p>
-        </p:txBody>
-      </p:sp>
-      <p:sp>
-        <p:nvSpPr>
-          <p:cNvPr id="5" name="TextBox 4"/>
-          <p:cNvSpPr txBox="1"/>
-          <p:nvPr/>
-        </p:nvSpPr>
-        <p:spPr>
-          <a:xfrm>
-            <a:off x="640080" y="2560320"/>
-            <a:ext cx="10972800" cy="3931920"/>
-          </a:xfrm>
-          <a:prstGeom prst="rect">
-            <a:avLst/>
-          </a:prstGeom>
-          <a:noFill/>
-        </p:spPr>
-        <p:txBody>
-          <a:bodyPr wrap="square">
-            <a:spAutoFit/>
-          </a:bodyPr>
-          <a:lstStyle/>
-          <a:p>
-            <a:pPr>
-              <a:spcAft>
-                <a:spcPts val="1400"/>
-              </a:spcAft>
-              <a:defRPr sz="2300">
-                <a:solidFill>
-                  <a:srgbClr val="F0F4FF"/>
-                </a:solidFill>
-                <a:latin typeface="DejaVu Sans"/>
-              </a:defRPr>
-            </a:pPr>
-            <a:r>
-              <a:t>• Vektor: dotaz → podobné texty → top‑k. Přirozený text, parafráze, epizody.</a:t>
-            </a:r>
-          </a:p>
-          <a:p>
-            <a:pPr>
-              <a:spcAft>
-                <a:spcPts val="1400"/>
-              </a:spcAft>
-              <a:defRPr sz="2300">
-                <a:solidFill>
-                  <a:srgbClr val="F0F4FF"/>
-                </a:solidFill>
-                <a:latin typeface="DejaVu Sans"/>
-              </a:defRPr>
-            </a:pPr>
-            <a:r>
-              <a:t>• Graf: entita → typované hrany → sousedé / cesty. Vazby, dopady, zdroje.</a:t>
-            </a:r>
-          </a:p>
-          <a:p>
-            <a:pPr>
-              <a:spcAft>
-                <a:spcPts val="1400"/>
-              </a:spcAft>
-              <a:defRPr sz="2300">
-                <a:solidFill>
-                  <a:srgbClr val="F0F4FF"/>
-                </a:solidFill>
-                <a:latin typeface="DejaVu Sans"/>
-              </a:defRPr>
-            </a:pPr>
-            <a:r>
-              <a:t>• Vektor potřebuje metadata pro čas, tenant a autoritu.</a:t>
-            </a:r>
-          </a:p>
-          <a:p>
-            <a:pPr>
-              <a:spcAft>
-                <a:spcPts val="1400"/>
-              </a:spcAft>
-              <a:defRPr sz="2300">
-                <a:solidFill>
-                  <a:srgbClr val="F0F4FF"/>
-                </a:solidFill>
-                <a:latin typeface="DejaVu Sans"/>
-              </a:defRPr>
-            </a:pPr>
-            <a:r>
-              <a:t>• Graf potřebuje extrakci, sjednocení entit a správné směry hran.</a:t>
-            </a:r>
-          </a:p>
-          <a:p>
-            <a:pPr>
-              <a:spcAft>
-                <a:spcPts val="1400"/>
-              </a:spcAft>
-              <a:defRPr sz="2300">
-                <a:solidFill>
-                  <a:srgbClr val="F0F4FF"/>
-                </a:solidFill>
-                <a:latin typeface="DejaVu Sans"/>
-              </a:defRPr>
-            </a:pPr>
-            <a:r>
-              <a:t>• Obě varianty mohou používat stejné SQL úložiště.</a:t>
-            </a:r>
-          </a:p>
-        </p:txBody>
-      </p:sp>
+      </p:pic>
     </p:spTree>
   </p:cSld>
   <p:clrMapOvr>
@@ -6193,7 +7055,85 @@
         </p:nvSpPr>
         <p:spPr>
           <a:xfrm>
-            <a:off x="548640" y="182880"/>
+            <a:off x="457200" y="164592"/>
+            <a:ext cx="10972800" cy="274320"/>
+          </a:xfrm>
+          <a:prstGeom prst="rect">
+            <a:avLst/>
+          </a:prstGeom>
+          <a:noFill/>
+        </p:spPr>
+        <p:txBody>
+          <a:bodyPr wrap="square">
+            <a:spAutoFit/>
+          </a:bodyPr>
+          <a:lstStyle/>
+          <a:p>
+            <a:pPr>
+              <a:spcAft>
+                <a:spcPts val="1400"/>
+              </a:spcAft>
+              <a:defRPr sz="1000">
+                <a:solidFill>
+                  <a:srgbClr val="A9BBD6"/>
+                </a:solidFill>
+                <a:latin typeface="DejaVu Sans"/>
+              </a:defRPr>
+            </a:pPr>
+            <a:r>
+              <a:t>LLM MEMORY LAB · 06/12 · MODELOVÁ BANKOVNÍ PLATFORMA</a:t>
+            </a:r>
+          </a:p>
+        </p:txBody>
+      </p:sp>
+      <p:sp>
+        <p:nvSpPr>
+          <p:cNvPr id="3" name="TextBox 2"/>
+          <p:cNvSpPr txBox="1"/>
+          <p:nvPr/>
+        </p:nvSpPr>
+        <p:spPr>
+          <a:xfrm>
+            <a:off x="457200" y="566928"/>
+            <a:ext cx="10972800" cy="457200"/>
+          </a:xfrm>
+          <a:prstGeom prst="rect">
+            <a:avLst/>
+          </a:prstGeom>
+          <a:noFill/>
+        </p:spPr>
+        <p:txBody>
+          <a:bodyPr wrap="square">
+            <a:spAutoFit/>
+          </a:bodyPr>
+          <a:lstStyle/>
+          <a:p>
+            <a:pPr>
+              <a:spcAft>
+                <a:spcPts val="1400"/>
+              </a:spcAft>
+              <a:defRPr sz="2700">
+                <a:solidFill>
+                  <a:srgbClr val="F0F4FF"/>
+                </a:solidFill>
+                <a:latin typeface="DejaVu Sans"/>
+              </a:defRPr>
+            </a:pPr>
+            <a:r>
+              <a:t>Feature a aktuální mechanismus</a:t>
+            </a:r>
+          </a:p>
+        </p:txBody>
+      </p:sp>
+      <p:sp>
+        <p:nvSpPr>
+          <p:cNvPr id="4" name="TextBox 3"/>
+          <p:cNvSpPr txBox="1"/>
+          <p:nvPr/>
+        </p:nvSpPr>
+        <p:spPr>
+          <a:xfrm>
+            <a:off x="457200" y="1060704"/>
             <a:ext cx="10972800" cy="365760"/>
           </a:xfrm>
           <a:prstGeom prst="rect">
@@ -6211,184 +7151,43 @@
               <a:spcAft>
                 <a:spcPts val="1400"/>
               </a:spcAft>
-              <a:defRPr sz="1200">
-                <a:solidFill>
-                  <a:srgbClr val="A9BBD6"/>
+              <a:defRPr sz="1600">
+                <a:solidFill>
+                  <a:srgbClr val="75DFC8"/>
                 </a:solidFill>
                 <a:latin typeface="DejaVu Sans"/>
               </a:defRPr>
             </a:pPr>
             <a:r>
-              <a:t>LLM MEMORY LAB · 06/12</a:t>
-            </a:r>
-          </a:p>
-        </p:txBody>
-      </p:sp>
-      <p:sp>
-        <p:nvSpPr>
-          <p:cNvPr id="3" name="TextBox 2"/>
-          <p:cNvSpPr txBox="1"/>
+              <a:t>Dva další průchody nad stejnou modelovou platformou</a:t>
+            </a:r>
+          </a:p>
+        </p:txBody>
+      </p:sp>
+      <p:pic>
+        <p:nvPicPr>
+          <p:cNvPr id="5" name="Picture 4" descr="bank-feature-evidence.png"/>
+          <p:cNvPicPr>
+            <a:picLocks noChangeAspect="1"/>
+          </p:cNvPicPr>
           <p:nvPr/>
-        </p:nvSpPr>
+        </p:nvPicPr>
+        <p:blipFill>
+          <a:blip r:embed="rId2"/>
+          <a:stretch>
+            <a:fillRect/>
+          </a:stretch>
+        </p:blipFill>
         <p:spPr>
           <a:xfrm>
-            <a:off x="548640" y="731520"/>
-            <a:ext cx="10972800" cy="1005840"/>
+            <a:off x="457200" y="1508760"/>
+            <a:ext cx="11247120" cy="5303520"/>
           </a:xfrm>
           <a:prstGeom prst="rect">
             <a:avLst/>
           </a:prstGeom>
-          <a:noFill/>
         </p:spPr>
-        <p:txBody>
-          <a:bodyPr wrap="square">
-            <a:spAutoFit/>
-          </a:bodyPr>
-          <a:lstStyle/>
-          <a:p>
-            <a:pPr>
-              <a:spcAft>
-                <a:spcPts val="1400"/>
-              </a:spcAft>
-              <a:defRPr sz="3200">
-                <a:solidFill>
-                  <a:srgbClr val="F0F4FF"/>
-                </a:solidFill>
-                <a:latin typeface="DejaVu Sans"/>
-              </a:defRPr>
-            </a:pPr>
-            <a:r>
-              <a:t>Živá ukázka: najdi chybějící hranu</a:t>
-            </a:r>
-          </a:p>
-        </p:txBody>
-      </p:sp>
-      <p:sp>
-        <p:nvSpPr>
-          <p:cNvPr id="4" name="TextBox 3"/>
-          <p:cNvSpPr txBox="1"/>
-          <p:nvPr/>
-        </p:nvSpPr>
-        <p:spPr>
-          <a:xfrm>
-            <a:off x="548640" y="1783080"/>
-            <a:ext cx="10972800" cy="548640"/>
-          </a:xfrm>
-          <a:prstGeom prst="rect">
-            <a:avLst/>
-          </a:prstGeom>
-          <a:noFill/>
-        </p:spPr>
-        <p:txBody>
-          <a:bodyPr wrap="square">
-            <a:spAutoFit/>
-          </a:bodyPr>
-          <a:lstStyle/>
-          <a:p>
-            <a:pPr>
-              <a:spcAft>
-                <a:spcPts val="1400"/>
-              </a:spcAft>
-              <a:defRPr sz="2100">
-                <a:solidFill>
-                  <a:srgbClr val="75DFC8"/>
-                </a:solidFill>
-                <a:latin typeface="DejaVu Sans"/>
-              </a:defRPr>
-            </a:pPr>
-            <a:r>
-              <a:t>Nejdřív tip, potom důkazy</a:t>
-            </a:r>
-          </a:p>
-        </p:txBody>
-      </p:sp>
-      <p:sp>
-        <p:nvSpPr>
-          <p:cNvPr id="5" name="TextBox 4"/>
-          <p:cNvSpPr txBox="1"/>
-          <p:nvPr/>
-        </p:nvSpPr>
-        <p:spPr>
-          <a:xfrm>
-            <a:off x="640080" y="2560320"/>
-            <a:ext cx="10972800" cy="3931920"/>
-          </a:xfrm>
-          <a:prstGeom prst="rect">
-            <a:avLst/>
-          </a:prstGeom>
-          <a:noFill/>
-        </p:spPr>
-        <p:txBody>
-          <a:bodyPr wrap="square">
-            <a:spAutoFit/>
-          </a:bodyPr>
-          <a:lstStyle/>
-          <a:p>
-            <a:pPr>
-              <a:spcAft>
-                <a:spcPts val="1400"/>
-              </a:spcAft>
-              <a:defRPr sz="2300">
-                <a:solidFill>
-                  <a:srgbClr val="F0F4FF"/>
-                </a:solidFill>
-                <a:latin typeface="DejaVu Sans"/>
-              </a:defRPr>
-            </a:pPr>
-            <a:r>
-              <a:t>• Otevřete ukázku níže nebo demo.html.</a:t>
-            </a:r>
-          </a:p>
-          <a:p>
-            <a:pPr>
-              <a:spcAft>
-                <a:spcPts val="1400"/>
-              </a:spcAft>
-              <a:defRPr sz="2300">
-                <a:solidFill>
-                  <a:srgbClr val="F0F4FF"/>
-                </a:solidFill>
-                <a:latin typeface="DejaVu Sans"/>
-              </a:defRPr>
-            </a:pPr>
-            <a:r>
-              <a:t>• Zvolte B a porovnejte vector s graph.</a:t>
-            </a:r>
-          </a:p>
-          <a:p>
-            <a:pPr>
-              <a:spcAft>
-                <a:spcPts val="1400"/>
-              </a:spcAft>
-              <a:defRPr sz="2300">
-                <a:solidFill>
-                  <a:srgbClr val="F0F4FF"/>
-                </a:solidFill>
-                <a:latin typeface="DejaVu Sans"/>
-              </a:defRPr>
-            </a:pPr>
-            <a:r>
-              <a:t>• Zvolte A: samotný graf nemá vyhledávač epizod.</a:t>
-            </a:r>
-          </a:p>
-          <a:p>
-            <a:pPr>
-              <a:spcAft>
-                <a:spcPts val="1400"/>
-              </a:spcAft>
-              <a:defRPr sz="2300">
-                <a:solidFill>
-                  <a:srgbClr val="F0F4FF"/>
-                </a:solidFill>
-                <a:latin typeface="DejaVu Sans"/>
-              </a:defRPr>
-            </a:pPr>
-            <a:r>
-              <a:t>• Skutečný kód: source-demo.html — import → reexport → normalize.</a:t>
-            </a:r>
-          </a:p>
-        </p:txBody>
-      </p:sp>
+      </p:pic>
     </p:spTree>
   </p:cSld>
   <p:clrMapOvr>
@@ -6488,7 +7287,7 @@
               </a:defRPr>
             </a:pPr>
             <a:r>
-              <a:t>Jak jsme měřili</a:t>
+              <a:t>Co jsme opravdu měřili?</a:t>
             </a:r>
           </a:p>
         </p:txBody>
@@ -6527,7 +7326,7 @@
               </a:defRPr>
             </a:pPr>
             <a:r>
-              <a:t>Retrieval, nikoli inteligenci agenta</a:t>
+              <a:t>Tři bankovní otázky nad spustitelným modelovým kódem</a:t>
             </a:r>
           </a:p>
         </p:txBody>
@@ -6541,7 +7340,7 @@
         <p:spPr>
           <a:xfrm>
             <a:off x="640080" y="2560320"/>
-            <a:ext cx="10972800" cy="3931920"/>
+            <a:ext cx="10972800" cy="3200400"/>
           </a:xfrm>
           <a:prstGeom prst="rect">
             <a:avLst/>
@@ -6558,7 +7357,7 @@
               <a:spcAft>
                 <a:spcPts val="1400"/>
               </a:spcAft>
-              <a:defRPr sz="2300">
+              <a:defRPr sz="2000">
                 <a:solidFill>
                   <a:srgbClr val="F0F4FF"/>
                 </a:solidFill>
@@ -6566,7 +7365,7 @@
               </a:defRPr>
             </a:pPr>
             <a:r>
-              <a:t>• 48 dokumentů • 24 dotazů • top‑k = 2 • 50 opakování/dotaz.</a:t>
+              <a:t>• Gold je předem určený seznam kódu, konfigurace a zdrojů potřebných k odpovědi.</a:t>
             </a:r>
           </a:p>
           <a:p>
@@ -6574,7 +7373,7 @@
               <a:spcAft>
                 <a:spcPts val="1400"/>
               </a:spcAft>
-              <a:defRPr sz="2300">
+              <a:defRPr sz="2000">
                 <a:solidFill>
                   <a:srgbClr val="F0F4FF"/>
                 </a:solidFill>
@@ -6582,7 +7381,7 @@
               </a:defRPr>
             </a:pPr>
             <a:r>
-              <a:t>• Gold = ručně určená ID potřebných důkazů.</a:t>
+              <a:t>• Úplnost = všechny důkazy; recall = podíl nalezených potřebných důkazů.</a:t>
             </a:r>
           </a:p>
           <a:p>
@@ -6590,7 +7389,7 @@
               <a:spcAft>
                 <a:spcPts val="1400"/>
               </a:spcAft>
-              <a:defRPr sz="2300">
+              <a:defRPr sz="2000">
                 <a:solidFill>
                   <a:srgbClr val="F0F4FF"/>
                 </a:solidFill>
@@ -6598,7 +7397,7 @@
               </a:defRPr>
             </a:pPr>
             <a:r>
-              <a:t>• Úplnost = vráceny všechny gold dokumenty; recall = podíl gold.</a:t>
+              <a:t>• Srovnáváme celý archiv, TF-IDF top-4 a graf s registrem nasazené verze.</a:t>
             </a:r>
           </a:p>
           <a:p>
@@ -6606,7 +7405,7 @@
               <a:spcAft>
                 <a:spcPts val="1400"/>
               </a:spcAft>
-              <a:defRPr sz="2300">
+              <a:defRPr sz="2000">
                 <a:solidFill>
                   <a:srgbClr val="F0F4FF"/>
                 </a:solidFill>
@@ -6614,23 +7413,46 @@
               </a:defRPr>
             </a:pPr>
             <a:r>
-              <a:t>• Precision = podíl relevantních dokumentů mezi vrácenými.</a:t>
-            </a:r>
-          </a:p>
+              <a:t>• Měříme bajty podkladů a čas hledání; LLM ani produkty zde neběží.</a:t>
+            </a:r>
+          </a:p>
+        </p:txBody>
+      </p:sp>
+      <p:sp>
+        <p:nvSpPr>
+          <p:cNvPr id="6" name="TextBox 5"/>
+          <p:cNvSpPr txBox="1"/>
+          <p:nvPr/>
+        </p:nvSpPr>
+        <p:spPr>
+          <a:xfrm>
+            <a:off x="640080" y="5806440"/>
+            <a:ext cx="10972800" cy="868680"/>
+          </a:xfrm>
+          <a:prstGeom prst="rect">
+            <a:avLst/>
+          </a:prstGeom>
+          <a:noFill/>
+        </p:spPr>
+        <p:txBody>
+          <a:bodyPr wrap="square">
+            <a:spAutoFit/>
+          </a:bodyPr>
+          <a:lstStyle/>
           <a:p>
             <a:pPr>
               <a:spcAft>
                 <a:spcPts val="1400"/>
               </a:spcAft>
-              <a:defRPr sz="2300">
-                <a:solidFill>
-                  <a:srgbClr val="F0F4FF"/>
+              <a:defRPr sz="1600">
+                <a:solidFill>
+                  <a:srgbClr val="75DFC8"/>
                 </a:solidFill>
                 <a:latin typeface="DejaVu Sans"/>
               </a:defRPr>
             </a:pPr>
             <a:r>
-              <a:t>• Kontext = UTF‑8 bajty; čas = warm retrieval v procesu.</a:t>
+              <a:t>U dopadů feature potřebujeme 3 důkazy; 1 nalezený znamená recall 1/3 a neúplnou odpověď.</a:t>
             </a:r>
           </a:p>
         </p:txBody>
@@ -6734,7 +7556,7 @@
               </a:defRPr>
             </a:pPr>
             <a:r>
-              <a:t>Vlastní výsledky</a:t>
+              <a:t>Výsledky bankovní ukázky</a:t>
             </a:r>
           </a:p>
         </p:txBody>
@@ -6773,7 +7595,7 @@
               </a:defRPr>
             </a:pPr>
             <a:r>
-              <a:t>Jeden běh; reprodukovatelné v results.json</a:t>
+              <a:t>Tři diagnostické otázky · nejde o žebříček produktů</a:t>
             </a:r>
           </a:p>
         </p:txBody>
@@ -6802,6 +7624,45 @@
           </a:prstGeom>
         </p:spPr>
       </p:pic>
+      <p:sp>
+        <p:nvSpPr>
+          <p:cNvPr id="6" name="TextBox 5"/>
+          <p:cNvSpPr txBox="1"/>
+          <p:nvPr/>
+        </p:nvSpPr>
+        <p:spPr>
+          <a:xfrm>
+            <a:off x="640080" y="5806440"/>
+            <a:ext cx="10972800" cy="868680"/>
+          </a:xfrm>
+          <a:prstGeom prst="rect">
+            <a:avLst/>
+          </a:prstGeom>
+          <a:noFill/>
+        </p:spPr>
+        <p:txBody>
+          <a:bodyPr wrap="square">
+            <a:spAutoFit/>
+          </a:bodyPr>
+          <a:lstStyle/>
+          <a:p>
+            <a:pPr>
+              <a:spcAft>
+                <a:spcPts val="1400"/>
+              </a:spcAft>
+              <a:defRPr sz="1600">
+                <a:solidFill>
+                  <a:srgbClr val="75DFC8"/>
+                </a:solidFill>
+                <a:latin typeface="DejaVu Sans"/>
+              </a:defRPr>
+            </a:pPr>
+            <a:r>
+              <a:t>Strukturované vybavení vrací více důkazů než top-4; poctivě porovnáváme i množství textu.</a:t>
+            </a:r>
+          </a:p>
+        </p:txBody>
+      </p:sp>
     </p:spTree>
   </p:cSld>
   <p:clrMapOvr>
@@ -6901,7 +7762,7 @@
               </a:defRPr>
             </a:pPr>
             <a:r>
-              <a:t>Změňme top‑k</a:t>
+              <a:t>Jak se v nástrojích orientovat?</a:t>
             </a:r>
           </a:p>
         </p:txBody>
@@ -6940,7 +7801,7 @@
               </a:defRPr>
             </a:pPr>
             <a:r>
-              <a:t>Více textu může pomoci, ale také zaplnit prompt</a:t>
+              <a:t>Vybírejte podle otázky, kterou má agent zvládnout</a:t>
             </a:r>
           </a:p>
         </p:txBody>
@@ -6954,7 +7815,7 @@
         <p:spPr>
           <a:xfrm>
             <a:off x="640080" y="2560320"/>
-            <a:ext cx="10972800" cy="3931920"/>
+            <a:ext cx="10972800" cy="3200400"/>
           </a:xfrm>
           <a:prstGeom prst="rect">
             <a:avLst/>
@@ -6971,7 +7832,7 @@
               <a:spcAft>
                 <a:spcPts val="1400"/>
               </a:spcAft>
-              <a:defRPr sz="2300">
+              <a:defRPr sz="2000">
                 <a:solidFill>
                   <a:srgbClr val="F0F4FF"/>
                 </a:solidFill>
@@ -6979,7 +7840,7 @@
               </a:defRPr>
             </a:pPr>
             <a:r>
-              <a:t>• k=1: úplné důkazy 16/24 · 98 B</a:t>
+              <a:t>• Graphify a GitNexus mapují kód: kde je funkce a na čem závisí její použití?</a:t>
             </a:r>
           </a:p>
           <a:p>
@@ -6987,7 +7848,7 @@
               <a:spcAft>
                 <a:spcPts val="1400"/>
               </a:spcAft>
-              <a:defRPr sz="2300">
+              <a:defRPr sz="2000">
                 <a:solidFill>
                   <a:srgbClr val="F0F4FF"/>
                 </a:solidFill>
@@ -6995,7 +7856,7 @@
               </a:defRPr>
             </a:pPr>
             <a:r>
-              <a:t>• k=2: úplné důkazy 16/24 · 196 B</a:t>
+              <a:t>• Graphiti řeší fakta měnící se v čase: kdo byl a kdo je vlastníkem?</a:t>
             </a:r>
           </a:p>
           <a:p>
@@ -7003,7 +7864,7 @@
               <a:spcAft>
                 <a:spcPts val="1400"/>
               </a:spcAft>
-              <a:defRPr sz="2300">
+              <a:defRPr sz="2000">
                 <a:solidFill>
                   <a:srgbClr val="F0F4FF"/>
                 </a:solidFill>
@@ -7011,7 +7872,7 @@
               </a:defRPr>
             </a:pPr>
             <a:r>
-              <a:t>• k=4: úplné důkazy 16/24 · 407 B</a:t>
+              <a:t>• Cognee a Mem0 pomáhají s pamětí znalostí, konverzací a uživatelského kontextu.</a:t>
             </a:r>
           </a:p>
           <a:p>
@@ -7019,7 +7880,7 @@
               <a:spcAft>
                 <a:spcPts val="1400"/>
               </a:spcAft>
-              <a:defRPr sz="2300">
+              <a:defRPr sz="2000">
                 <a:solidFill>
                   <a:srgbClr val="F0F4FF"/>
                 </a:solidFill>
@@ -7027,7 +7888,46 @@
               </a:defRPr>
             </a:pPr>
             <a:r>
-              <a:t>• k=8: úplné důkazy 16/24 · 803 B</a:t>
+              <a:t>• LightRAG a Microsoft GraphRAG propojují dokumenty; GraphRAG využívá i souhrny komunit.</a:t>
+            </a:r>
+          </a:p>
+        </p:txBody>
+      </p:sp>
+      <p:sp>
+        <p:nvSpPr>
+          <p:cNvPr id="6" name="TextBox 5"/>
+          <p:cNvSpPr txBox="1"/>
+          <p:nvPr/>
+        </p:nvSpPr>
+        <p:spPr>
+          <a:xfrm>
+            <a:off x="640080" y="5806440"/>
+            <a:ext cx="10972800" cy="868680"/>
+          </a:xfrm>
+          <a:prstGeom prst="rect">
+            <a:avLst/>
+          </a:prstGeom>
+          <a:noFill/>
+        </p:spPr>
+        <p:txBody>
+          <a:bodyPr wrap="square">
+            <a:spAutoFit/>
+          </a:bodyPr>
+          <a:lstStyle/>
+          <a:p>
+            <a:pPr>
+              <a:spcAft>
+                <a:spcPts val="1400"/>
+              </a:spcAft>
+              <a:defRPr sz="1600">
+                <a:solidFill>
+                  <a:srgbClr val="75DFC8"/>
+                </a:solidFill>
+                <a:latin typeface="DejaVu Sans"/>
+              </a:defRPr>
+            </a:pPr>
+            <a:r>
+              <a:t>Repozitář a dopady feature → Graphify/GitNexus. Historie pravidel → Graphiti + verzovaný stav.</a:t>
             </a:r>
           </a:p>
         </p:txBody>

</xml_diff>